<commit_message>
Seeds: the Day fold gets its earlier-today visit; baselines + deck refreshed; tidewave click-to-source stays off (conflict documented)
</commit_message>
<xml_diff>
--- a/docs/capstone-deck.pptx
+++ b/docs/capstone-deck.pptx
@@ -16,9 +16,10 @@
     <p:sldId id="264" r:id="rId10"/>
     <p:sldId id="265" r:id="rId11"/>
     <p:sldId id="266" r:id="rId12"/>
+    <p:sldId id="267" r:id="rId13"/>
   </p:sldIdLst>
   <p:notesMasterIdLst>
-    <p:notesMasterId r:id="rId13"/>
+    <p:notesMasterId r:id="rId14"/>
   </p:notesMasterIdLst>
   <p:sldSz cx="12192000" cy="6858000"/>
   <p:notesSz cx="6858000" cy="12192000"/>
@@ -712,6 +713,94 @@
             <a:fld id="{F7021451-1387-4CA6-816F-3879F97B5CBC}" type="slidenum">
               <a:rPr lang="en-US"/>
               <a:t>11</a:t>
+            </a:fld>
+            <a:endParaRPr lang="en-US"/>
+          </a:p>
+        </p:txBody>
+      </p:sp>
+    </p:spTree>
+    <p:extLst>
+      <p:ext uri="{BB962C8B-B14F-4D97-AF65-F5344CB8AC3E}">
+        <p14:creationId xmlns:p14="http://schemas.microsoft.com/office/powerpoint/2010/main" val="1024086991"/>
+      </p:ext>
+    </p:extLst>
+  </p:cSld>
+  <p:clrMapOvr>
+    <a:masterClrMapping/>
+  </p:clrMapOvr>
+</p:notes>
+</file>
+
+<file path=ppt/notesSlides/notesSlide12.xml><?xml version="1.0" encoding="utf-8"?>
+<p:notes xmlns:a="http://schemas.openxmlformats.org/drawingml/2006/main" xmlns:r="http://schemas.openxmlformats.org/officeDocument/2006/relationships" xmlns:p="http://schemas.openxmlformats.org/presentationml/2006/main">
+  <p:cSld>
+    <p:spTree>
+      <p:nvGrpSpPr>
+        <p:cNvPr id="1" name=""/>
+        <p:cNvGrpSpPr/>
+        <p:nvPr/>
+      </p:nvGrpSpPr>
+      <p:grpSpPr>
+        <a:xfrm>
+          <a:off x="0" y="0"/>
+          <a:ext cx="0" cy="0"/>
+          <a:chOff x="0" y="0"/>
+          <a:chExt cx="0" cy="0"/>
+        </a:xfrm>
+      </p:grpSpPr>
+      <p:sp>
+        <p:nvSpPr>
+          <p:cNvPr id="2" name="Slide Image Placeholder 1"/>
+          <p:cNvSpPr>
+            <a:spLocks noGrp="1" noRot="1" noChangeAspect="1"/>
+          </p:cNvSpPr>
+          <p:nvPr>
+            <p:ph type="sldImg"/>
+          </p:nvPr>
+        </p:nvSpPr>
+        <p:spPr/>
+      </p:sp>
+      <p:sp>
+        <p:nvSpPr>
+          <p:cNvPr id="3" name="Notes Placeholder 2"/>
+          <p:cNvSpPr>
+            <a:spLocks noGrp="1"/>
+          </p:cNvSpPr>
+          <p:nvPr>
+            <p:ph type="body" idx="1"/>
+          </p:nvPr>
+        </p:nvSpPr>
+        <p:spPr/>
+        <p:txBody>
+          <a:bodyPr/>
+          <a:lstStyle/>
+          <a:p>
+            <a:r>
+              <a:rPr lang="en-US" dirty="0"/>
+              <a:t/>
+            </a:r>
+            <a:endParaRPr lang="en-US" dirty="0"/>
+          </a:p>
+        </p:txBody>
+      </p:sp>
+      <p:sp>
+        <p:nvSpPr>
+          <p:cNvPr id="4" name="Slide Number Placeholder 3"/>
+          <p:cNvSpPr>
+            <a:spLocks noGrp="1"/>
+          </p:cNvSpPr>
+          <p:nvPr>
+            <p:ph type="sldNum" sz="quarter" idx="10"/>
+          </p:nvPr>
+        </p:nvSpPr>
+        <p:spPr/>
+        <p:txBody>
+          <a:bodyPr/>
+          <a:lstStyle/>
+          <a:p>
+            <a:fld id="{F7021451-1387-4CA6-816F-3879F97B5CBC}" type="slidenum">
+              <a:rPr lang="en-US"/>
+              <a:t>12</a:t>
             </a:fld>
             <a:endParaRPr lang="en-US"/>
           </a:p>
@@ -2144,6 +2233,700 @@
                 <a:ea typeface="Arial" pitchFamily="34" charset="-122"/>
                 <a:cs typeface="Arial" pitchFamily="34" charset="-120"/>
               </a:rPr>
+              <a:t>THE AGENT STORY</a:t>
+            </a:r>
+            <a:endParaRPr lang="en-US" sz="1200" dirty="0"/>
+          </a:p>
+        </p:txBody>
+      </p:sp>
+      <p:sp>
+        <p:nvSpPr>
+          <p:cNvPr id="3" name="Text 1"/>
+          <p:cNvSpPr txBox="1"/>
+          <p:nvPr/>
+        </p:nvSpPr>
+        <p:spPr>
+          <a:xfrm>
+            <a:off x="484632" y="566928"/>
+            <a:ext cx="10515600" cy="685800"/>
+          </a:xfrm>
+          <a:prstGeom prst="rect">
+            <a:avLst/>
+          </a:prstGeom>
+          <a:noFill/>
+          <a:ln/>
+        </p:spPr>
+        <p:txBody>
+          <a:bodyPr wrap="square" lIns="0" tIns="0" rIns="0" bIns="0" rtlCol="0" anchor="ctr"/>
+          <a:lstStyle/>
+          <a:p>
+            <a:pPr indent="0" marL="0">
+              <a:buNone/>
+            </a:pPr>
+            <a:r>
+              <a:rPr lang="en-US" sz="3000" b="1" dirty="0">
+                <a:solidFill>
+                  <a:srgbClr val="141414"/>
+                </a:solidFill>
+                <a:latin typeface="Arial" pitchFamily="34" charset="0"/>
+                <a:ea typeface="Arial" pitchFamily="34" charset="-122"/>
+                <a:cs typeface="Arial" pitchFamily="34" charset="-120"/>
+              </a:rPr>
+              <a:t>The stack is agent-native, end to end</a:t>
+            </a:r>
+            <a:endParaRPr lang="en-US" sz="3000" dirty="0"/>
+          </a:p>
+        </p:txBody>
+      </p:sp>
+      <p:sp>
+        <p:nvSpPr>
+          <p:cNvPr id="4" name="Shape 2"/>
+          <p:cNvSpPr/>
+          <p:nvPr/>
+        </p:nvSpPr>
+        <p:spPr>
+          <a:xfrm>
+            <a:off x="502920" y="1691640"/>
+            <a:ext cx="11155680" cy="914400"/>
+          </a:xfrm>
+          <a:prstGeom prst="roundRect">
+            <a:avLst>
+              <a:gd name="adj" fmla="val 6000"/>
+            </a:avLst>
+          </a:prstGeom>
+          <a:solidFill>
+            <a:srgbClr val="FFFFFF"/>
+          </a:solidFill>
+          <a:ln w="25400">
+            <a:solidFill>
+              <a:srgbClr val="141414"/>
+            </a:solidFill>
+            <a:prstDash val="solid"/>
+          </a:ln>
+          <a:effectLst>
+            <a:outerShdw sx="100000" sy="100000" kx="0" ky="0" algn="bl" rotWithShape="0" blurRad="101600" dist="63500" dir="2700000">
+              <a:srgbClr val="141414">
+                <a:alpha val="100000"/>
+              </a:srgbClr>
+            </a:outerShdw>
+          </a:effectLst>
+        </p:spPr>
+      </p:sp>
+      <p:sp>
+        <p:nvSpPr>
+          <p:cNvPr id="5" name="Shape 3"/>
+          <p:cNvSpPr/>
+          <p:nvPr/>
+        </p:nvSpPr>
+        <p:spPr>
+          <a:xfrm>
+            <a:off x="777240" y="1975104"/>
+            <a:ext cx="1417320" cy="310896"/>
+          </a:xfrm>
+          <a:prstGeom prst="roundRect">
+            <a:avLst>
+              <a:gd name="adj" fmla="val 50000"/>
+            </a:avLst>
+          </a:prstGeom>
+          <a:solidFill>
+            <a:srgbClr val="DCE9FC"/>
+          </a:solidFill>
+          <a:ln w="22225">
+            <a:solidFill>
+              <a:srgbClr val="141414"/>
+            </a:solidFill>
+            <a:prstDash val="solid"/>
+          </a:ln>
+          <a:effectLst>
+            <a:outerShdw sx="100000" sy="100000" kx="0" ky="0" algn="bl" rotWithShape="0" blurRad="101600" dist="38100" dir="2700000">
+              <a:srgbClr val="141414">
+                <a:alpha val="100000"/>
+              </a:srgbClr>
+            </a:outerShdw>
+          </a:effectLst>
+        </p:spPr>
+      </p:sp>
+      <p:sp>
+        <p:nvSpPr>
+          <p:cNvPr id="6" name="Text 4"/>
+          <p:cNvSpPr txBox="1"/>
+          <p:nvPr/>
+        </p:nvSpPr>
+        <p:spPr>
+          <a:xfrm>
+            <a:off x="777240" y="1975104"/>
+            <a:ext cx="1417320" cy="310896"/>
+          </a:xfrm>
+          <a:prstGeom prst="rect">
+            <a:avLst/>
+          </a:prstGeom>
+          <a:noFill/>
+          <a:ln/>
+        </p:spPr>
+        <p:txBody>
+          <a:bodyPr wrap="square" lIns="0" tIns="0" rIns="0" bIns="0" rtlCol="0" anchor="ctr"/>
+          <a:lstStyle/>
+          <a:p>
+            <a:pPr algn="ctr" indent="0" marL="0">
+              <a:buNone/>
+            </a:pPr>
+            <a:r>
+              <a:rPr lang="en-US" sz="1100" b="1" dirty="0">
+                <a:solidFill>
+                  <a:srgbClr val="141414"/>
+                </a:solidFill>
+                <a:latin typeface="Arial" pitchFamily="34" charset="0"/>
+                <a:ea typeface="Arial" pitchFamily="34" charset="-122"/>
+                <a:cs typeface="Arial" pitchFamily="34" charset="-120"/>
+              </a:rPr>
+              <a:t>ash_agent_tools</a:t>
+            </a:r>
+            <a:endParaRPr lang="en-US" sz="1100" dirty="0"/>
+          </a:p>
+        </p:txBody>
+      </p:sp>
+      <p:sp>
+        <p:nvSpPr>
+          <p:cNvPr id="7" name="Text 5"/>
+          <p:cNvSpPr txBox="1"/>
+          <p:nvPr/>
+        </p:nvSpPr>
+        <p:spPr>
+          <a:xfrm>
+            <a:off x="3794760" y="1856232"/>
+            <a:ext cx="7680960" cy="621792"/>
+          </a:xfrm>
+          <a:prstGeom prst="rect">
+            <a:avLst/>
+          </a:prstGeom>
+          <a:noFill/>
+          <a:ln/>
+        </p:spPr>
+        <p:txBody>
+          <a:bodyPr wrap="square" lIns="0" tIns="0" rIns="0" bIns="0" rtlCol="0" anchor="ctr"/>
+          <a:lstStyle/>
+          <a:p>
+            <a:pPr indent="0" marL="0">
+              <a:buNone/>
+            </a:pPr>
+            <a:r>
+              <a:rPr lang="en-US" sz="1350" dirty="0">
+                <a:solidFill>
+                  <a:srgbClr val="141414"/>
+                </a:solidFill>
+                <a:latin typeface="Calibri" pitchFamily="34" charset="0"/>
+                <a:ea typeface="Calibri" pitchFamily="34" charset="-122"/>
+                <a:cs typeface="Calibri" pitchFamily="34" charset="-120"/>
+              </a:rPr>
+              <a:t>describe / can / evaluate / edit — the contract, readable by machines; semantic edits with compile gates</a:t>
+            </a:r>
+            <a:endParaRPr lang="en-US" sz="1350" dirty="0"/>
+          </a:p>
+        </p:txBody>
+      </p:sp>
+      <p:sp>
+        <p:nvSpPr>
+          <p:cNvPr id="8" name="Shape 6"/>
+          <p:cNvSpPr/>
+          <p:nvPr/>
+        </p:nvSpPr>
+        <p:spPr>
+          <a:xfrm>
+            <a:off x="502920" y="2770632"/>
+            <a:ext cx="11155680" cy="914400"/>
+          </a:xfrm>
+          <a:prstGeom prst="roundRect">
+            <a:avLst>
+              <a:gd name="adj" fmla="val 6000"/>
+            </a:avLst>
+          </a:prstGeom>
+          <a:solidFill>
+            <a:srgbClr val="FFFFFF"/>
+          </a:solidFill>
+          <a:ln w="25400">
+            <a:solidFill>
+              <a:srgbClr val="141414"/>
+            </a:solidFill>
+            <a:prstDash val="solid"/>
+          </a:ln>
+          <a:effectLst>
+            <a:outerShdw sx="100000" sy="100000" kx="0" ky="0" algn="bl" rotWithShape="0" blurRad="101600" dist="63500" dir="2700000">
+              <a:srgbClr val="141414">
+                <a:alpha val="100000"/>
+              </a:srgbClr>
+            </a:outerShdw>
+          </a:effectLst>
+        </p:spPr>
+      </p:sp>
+      <p:sp>
+        <p:nvSpPr>
+          <p:cNvPr id="9" name="Shape 7"/>
+          <p:cNvSpPr/>
+          <p:nvPr/>
+        </p:nvSpPr>
+        <p:spPr>
+          <a:xfrm>
+            <a:off x="777240" y="3054096"/>
+            <a:ext cx="1192378" cy="310896"/>
+          </a:xfrm>
+          <a:prstGeom prst="roundRect">
+            <a:avLst>
+              <a:gd name="adj" fmla="val 50000"/>
+            </a:avLst>
+          </a:prstGeom>
+          <a:solidFill>
+            <a:srgbClr val="DCE9FC"/>
+          </a:solidFill>
+          <a:ln w="22225">
+            <a:solidFill>
+              <a:srgbClr val="141414"/>
+            </a:solidFill>
+            <a:prstDash val="solid"/>
+          </a:ln>
+          <a:effectLst>
+            <a:outerShdw sx="100000" sy="100000" kx="0" ky="0" algn="bl" rotWithShape="0" blurRad="101600" dist="38100" dir="2700000">
+              <a:srgbClr val="141414">
+                <a:alpha val="100000"/>
+              </a:srgbClr>
+            </a:outerShdw>
+          </a:effectLst>
+        </p:spPr>
+      </p:sp>
+      <p:sp>
+        <p:nvSpPr>
+          <p:cNvPr id="10" name="Text 8"/>
+          <p:cNvSpPr txBox="1"/>
+          <p:nvPr/>
+        </p:nvSpPr>
+        <p:spPr>
+          <a:xfrm>
+            <a:off x="777240" y="3054096"/>
+            <a:ext cx="1192378" cy="310896"/>
+          </a:xfrm>
+          <a:prstGeom prst="rect">
+            <a:avLst/>
+          </a:prstGeom>
+          <a:noFill/>
+          <a:ln/>
+        </p:spPr>
+        <p:txBody>
+          <a:bodyPr wrap="square" lIns="0" tIns="0" rIns="0" bIns="0" rtlCol="0" anchor="ctr"/>
+          <a:lstStyle/>
+          <a:p>
+            <a:pPr algn="ctr" indent="0" marL="0">
+              <a:buNone/>
+            </a:pPr>
+            <a:r>
+              <a:rPr lang="en-US" sz="1100" b="1" dirty="0">
+                <a:solidFill>
+                  <a:srgbClr val="141414"/>
+                </a:solidFill>
+                <a:latin typeface="Arial" pitchFamily="34" charset="0"/>
+                <a:ea typeface="Arial" pitchFamily="34" charset="-122"/>
+                <a:cs typeface="Arial" pitchFamily="34" charset="-120"/>
+              </a:rPr>
+              <a:t>Tidewave MCP</a:t>
+            </a:r>
+            <a:endParaRPr lang="en-US" sz="1100" dirty="0"/>
+          </a:p>
+        </p:txBody>
+      </p:sp>
+      <p:sp>
+        <p:nvSpPr>
+          <p:cNvPr id="11" name="Text 9"/>
+          <p:cNvSpPr txBox="1"/>
+          <p:nvPr/>
+        </p:nvSpPr>
+        <p:spPr>
+          <a:xfrm>
+            <a:off x="3794760" y="2935224"/>
+            <a:ext cx="7680960" cy="621792"/>
+          </a:xfrm>
+          <a:prstGeom prst="rect">
+            <a:avLst/>
+          </a:prstGeom>
+          <a:noFill/>
+          <a:ln/>
+        </p:spPr>
+        <p:txBody>
+          <a:bodyPr wrap="square" lIns="0" tIns="0" rIns="0" bIns="0" rtlCol="0" anchor="ctr"/>
+          <a:lstStyle/>
+          <a:p>
+            <a:pPr indent="0" marL="0">
+              <a:buNone/>
+            </a:pPr>
+            <a:r>
+              <a:rPr lang="en-US" sz="1350" dirty="0">
+                <a:solidFill>
+                  <a:srgbClr val="141414"/>
+                </a:solidFill>
+                <a:latin typeface="Calibri" pitchFamily="34" charset="0"/>
+                <a:ea typeface="Calibri" pitchFamily="34" charset="-122"/>
+                <a:cs typeface="Calibri" pitchFamily="34" charset="-120"/>
+              </a:rPr>
+              <a:t>project_eval in the running app — Ash reflection, logs, SQL; get_docs at exact lockfile versions</a:t>
+            </a:r>
+            <a:endParaRPr lang="en-US" sz="1350" dirty="0"/>
+          </a:p>
+        </p:txBody>
+      </p:sp>
+      <p:sp>
+        <p:nvSpPr>
+          <p:cNvPr id="12" name="Shape 10"/>
+          <p:cNvSpPr/>
+          <p:nvPr/>
+        </p:nvSpPr>
+        <p:spPr>
+          <a:xfrm>
+            <a:off x="502920" y="3849624"/>
+            <a:ext cx="11155680" cy="914400"/>
+          </a:xfrm>
+          <a:prstGeom prst="roundRect">
+            <a:avLst>
+              <a:gd name="adj" fmla="val 6000"/>
+            </a:avLst>
+          </a:prstGeom>
+          <a:solidFill>
+            <a:srgbClr val="FFFFFF"/>
+          </a:solidFill>
+          <a:ln w="25400">
+            <a:solidFill>
+              <a:srgbClr val="141414"/>
+            </a:solidFill>
+            <a:prstDash val="solid"/>
+          </a:ln>
+          <a:effectLst>
+            <a:outerShdw sx="100000" sy="100000" kx="0" ky="0" algn="bl" rotWithShape="0" blurRad="101600" dist="63500" dir="2700000">
+              <a:srgbClr val="141414">
+                <a:alpha val="100000"/>
+              </a:srgbClr>
+            </a:outerShdw>
+          </a:effectLst>
+        </p:spPr>
+      </p:sp>
+      <p:sp>
+        <p:nvSpPr>
+          <p:cNvPr id="13" name="Shape 11"/>
+          <p:cNvSpPr/>
+          <p:nvPr/>
+        </p:nvSpPr>
+        <p:spPr>
+          <a:xfrm>
+            <a:off x="777240" y="4133088"/>
+            <a:ext cx="1792224" cy="310896"/>
+          </a:xfrm>
+          <a:prstGeom prst="roundRect">
+            <a:avLst>
+              <a:gd name="adj" fmla="val 50000"/>
+            </a:avLst>
+          </a:prstGeom>
+          <a:solidFill>
+            <a:srgbClr val="DCE9FC"/>
+          </a:solidFill>
+          <a:ln w="22225">
+            <a:solidFill>
+              <a:srgbClr val="141414"/>
+            </a:solidFill>
+            <a:prstDash val="solid"/>
+          </a:ln>
+          <a:effectLst>
+            <a:outerShdw sx="100000" sy="100000" kx="0" ky="0" algn="bl" rotWithShape="0" blurRad="101600" dist="38100" dir="2700000">
+              <a:srgbClr val="141414">
+                <a:alpha val="100000"/>
+              </a:srgbClr>
+            </a:outerShdw>
+          </a:effectLst>
+        </p:spPr>
+      </p:sp>
+      <p:sp>
+        <p:nvSpPr>
+          <p:cNvPr id="14" name="Text 12"/>
+          <p:cNvSpPr txBox="1"/>
+          <p:nvPr/>
+        </p:nvSpPr>
+        <p:spPr>
+          <a:xfrm>
+            <a:off x="777240" y="4133088"/>
+            <a:ext cx="1792224" cy="310896"/>
+          </a:xfrm>
+          <a:prstGeom prst="rect">
+            <a:avLst/>
+          </a:prstGeom>
+          <a:noFill/>
+          <a:ln/>
+        </p:spPr>
+        <p:txBody>
+          <a:bodyPr wrap="square" lIns="0" tIns="0" rIns="0" bIns="0" rtlCol="0" anchor="ctr"/>
+          <a:lstStyle/>
+          <a:p>
+            <a:pPr algn="ctr" indent="0" marL="0">
+              <a:buNone/>
+            </a:pPr>
+            <a:r>
+              <a:rPr lang="en-US" sz="1100" b="1" dirty="0">
+                <a:solidFill>
+                  <a:srgbClr val="141414"/>
+                </a:solidFill>
+                <a:latin typeface="Arial" pitchFamily="34" charset="0"/>
+                <a:ea typeface="Arial" pitchFamily="34" charset="-122"/>
+                <a:cs typeface="Arial" pitchFamily="34" charset="-120"/>
+              </a:rPr>
+              <a:t>Serena-grade editing</a:t>
+            </a:r>
+            <a:endParaRPr lang="en-US" sz="1100" dirty="0"/>
+          </a:p>
+        </p:txBody>
+      </p:sp>
+      <p:sp>
+        <p:nvSpPr>
+          <p:cNvPr id="15" name="Text 13"/>
+          <p:cNvSpPr txBox="1"/>
+          <p:nvPr/>
+        </p:nvSpPr>
+        <p:spPr>
+          <a:xfrm>
+            <a:off x="3794760" y="4014216"/>
+            <a:ext cx="7680960" cy="621792"/>
+          </a:xfrm>
+          <a:prstGeom prst="rect">
+            <a:avLst/>
+          </a:prstGeom>
+          <a:noFill/>
+          <a:ln/>
+        </p:spPr>
+        <p:txBody>
+          <a:bodyPr wrap="square" lIns="0" tIns="0" rIns="0" bIns="0" rtlCol="0" anchor="ctr"/>
+          <a:lstStyle/>
+          <a:p>
+            <a:pPr indent="0" marL="0">
+              <a:buNone/>
+            </a:pPr>
+            <a:r>
+              <a:rPr lang="en-US" sz="1350" dirty="0">
+                <a:solidFill>
+                  <a:srgbClr val="141414"/>
+                </a:solidFill>
+                <a:latin typeface="Calibri" pitchFamily="34" charset="0"/>
+                <a:ea typeface="Calibri" pitchFamily="34" charset="-122"/>
+                <a:cs typeface="Calibri" pitchFamily="34" charset="-120"/>
+              </a:rPr>
+              <a:t>create ops + batch apply + formatter contract — agents author Ash DSL safely</a:t>
+            </a:r>
+            <a:endParaRPr lang="en-US" sz="1350" dirty="0"/>
+          </a:p>
+        </p:txBody>
+      </p:sp>
+      <p:sp>
+        <p:nvSpPr>
+          <p:cNvPr id="16" name="Shape 14"/>
+          <p:cNvSpPr/>
+          <p:nvPr/>
+        </p:nvSpPr>
+        <p:spPr>
+          <a:xfrm>
+            <a:off x="502920" y="4928616"/>
+            <a:ext cx="11155680" cy="914400"/>
+          </a:xfrm>
+          <a:prstGeom prst="roundRect">
+            <a:avLst>
+              <a:gd name="adj" fmla="val 6000"/>
+            </a:avLst>
+          </a:prstGeom>
+          <a:solidFill>
+            <a:srgbClr val="FFFFFF"/>
+          </a:solidFill>
+          <a:ln w="25400">
+            <a:solidFill>
+              <a:srgbClr val="141414"/>
+            </a:solidFill>
+            <a:prstDash val="solid"/>
+          </a:ln>
+          <a:effectLst>
+            <a:outerShdw sx="100000" sy="100000" kx="0" ky="0" algn="bl" rotWithShape="0" blurRad="101600" dist="63500" dir="2700000">
+              <a:srgbClr val="141414">
+                <a:alpha val="100000"/>
+              </a:srgbClr>
+            </a:outerShdw>
+          </a:effectLst>
+        </p:spPr>
+      </p:sp>
+      <p:sp>
+        <p:nvSpPr>
+          <p:cNvPr id="17" name="Shape 15"/>
+          <p:cNvSpPr/>
+          <p:nvPr/>
+        </p:nvSpPr>
+        <p:spPr>
+          <a:xfrm>
+            <a:off x="777240" y="5212080"/>
+            <a:ext cx="1567282" cy="310896"/>
+          </a:xfrm>
+          <a:prstGeom prst="roundRect">
+            <a:avLst>
+              <a:gd name="adj" fmla="val 50000"/>
+            </a:avLst>
+          </a:prstGeom>
+          <a:solidFill>
+            <a:srgbClr val="FFD43B"/>
+          </a:solidFill>
+          <a:ln w="22225">
+            <a:solidFill>
+              <a:srgbClr val="141414"/>
+            </a:solidFill>
+            <a:prstDash val="solid"/>
+          </a:ln>
+          <a:effectLst>
+            <a:outerShdw sx="100000" sy="100000" kx="0" ky="0" algn="bl" rotWithShape="0" blurRad="101600" dist="38100" dir="2700000">
+              <a:srgbClr val="141414">
+                <a:alpha val="100000"/>
+              </a:srgbClr>
+            </a:outerShdw>
+          </a:effectLst>
+        </p:spPr>
+      </p:sp>
+      <p:sp>
+        <p:nvSpPr>
+          <p:cNvPr id="18" name="Text 16"/>
+          <p:cNvSpPr txBox="1"/>
+          <p:nvPr/>
+        </p:nvSpPr>
+        <p:spPr>
+          <a:xfrm>
+            <a:off x="777240" y="5212080"/>
+            <a:ext cx="1567282" cy="310896"/>
+          </a:xfrm>
+          <a:prstGeom prst="rect">
+            <a:avLst/>
+          </a:prstGeom>
+          <a:noFill/>
+          <a:ln/>
+        </p:spPr>
+        <p:txBody>
+          <a:bodyPr wrap="square" lIns="0" tIns="0" rIns="0" bIns="0" rtlCol="0" anchor="ctr"/>
+          <a:lstStyle/>
+          <a:p>
+            <a:pPr algn="ctr" indent="0" marL="0">
+              <a:buNone/>
+            </a:pPr>
+            <a:r>
+              <a:rPr lang="en-US" sz="1100" b="1" dirty="0">
+                <a:solidFill>
+                  <a:srgbClr val="141414"/>
+                </a:solidFill>
+                <a:latin typeface="Arial" pitchFamily="34" charset="0"/>
+                <a:ea typeface="Arial" pitchFamily="34" charset="-122"/>
+                <a:cs typeface="Arial" pitchFamily="34" charset="-120"/>
+              </a:rPr>
+              <a:t>The agent console</a:t>
+            </a:r>
+            <a:endParaRPr lang="en-US" sz="1100" dirty="0"/>
+          </a:p>
+        </p:txBody>
+      </p:sp>
+      <p:sp>
+        <p:nvSpPr>
+          <p:cNvPr id="19" name="Text 17"/>
+          <p:cNvSpPr txBox="1"/>
+          <p:nvPr/>
+        </p:nvSpPr>
+        <p:spPr>
+          <a:xfrm>
+            <a:off x="3794760" y="5093208"/>
+            <a:ext cx="7680960" cy="621792"/>
+          </a:xfrm>
+          <a:prstGeom prst="rect">
+            <a:avLst/>
+          </a:prstGeom>
+          <a:noFill/>
+          <a:ln/>
+        </p:spPr>
+        <p:txBody>
+          <a:bodyPr wrap="square" lIns="0" tIns="0" rIns="0" bIns="0" rtlCol="0" anchor="ctr"/>
+          <a:lstStyle/>
+          <a:p>
+            <a:pPr indent="0" marL="0">
+              <a:buNone/>
+            </a:pPr>
+            <a:r>
+              <a:rPr lang="en-US" sz="1350" dirty="0">
+                <a:solidFill>
+                  <a:srgbClr val="141414"/>
+                </a:solidFill>
+                <a:latin typeface="Calibri" pitchFamily="34" charset="0"/>
+                <a:ea typeface="Calibri" pitchFamily="34" charset="-122"/>
+                <a:cs typeface="Calibri" pitchFamily="34" charset="-120"/>
+              </a:rPr>
+              <a:t>in-app: ask for an interface, it composes and verifies a surface live (LLM-backed, works keyless for browsing)</a:t>
+            </a:r>
+            <a:endParaRPr lang="en-US" sz="1350" dirty="0"/>
+          </a:p>
+        </p:txBody>
+      </p:sp>
+    </p:spTree>
+  </p:cSld>
+  <p:clrMapOvr>
+    <a:masterClrMapping/>
+  </p:clrMapOvr>
+</p:sld>
+</file>
+
+<file path=ppt/slides/slide11.xml><?xml version="1.0" encoding="utf-8"?>
+<p:sld xmlns:a="http://schemas.openxmlformats.org/drawingml/2006/main" xmlns:r="http://schemas.openxmlformats.org/officeDocument/2006/relationships" xmlns:p="http://schemas.openxmlformats.org/presentationml/2006/main">
+  <p:cSld name="Slide 11">
+    <p:bg>
+      <p:bgPr>
+        <a:solidFill>
+          <a:srgbClr val="F2F7FE"/>
+        </a:solidFill>
+      </p:bgPr>
+    </p:bg>
+    <p:spTree>
+      <p:nvGrpSpPr>
+        <p:cNvPr id="1" name=""/>
+        <p:cNvGrpSpPr/>
+        <p:nvPr/>
+      </p:nvGrpSpPr>
+      <p:grpSpPr>
+        <a:xfrm>
+          <a:off x="0" y="0"/>
+          <a:ext cx="0" cy="0"/>
+          <a:chOff x="0" y="0"/>
+          <a:chExt cx="0" cy="0"/>
+        </a:xfrm>
+      </p:grpSpPr>
+      <p:sp>
+        <p:nvSpPr>
+          <p:cNvPr id="2" name="Text 0"/>
+          <p:cNvSpPr txBox="1"/>
+          <p:nvPr/>
+        </p:nvSpPr>
+        <p:spPr>
+          <a:xfrm>
+            <a:off x="502920" y="310896"/>
+            <a:ext cx="8229600" cy="292608"/>
+          </a:xfrm>
+          <a:prstGeom prst="rect">
+            <a:avLst/>
+          </a:prstGeom>
+          <a:noFill/>
+          <a:ln/>
+        </p:spPr>
+        <p:txBody>
+          <a:bodyPr wrap="square" lIns="0" tIns="0" rIns="0" bIns="0" rtlCol="0" anchor="ctr"/>
+          <a:lstStyle/>
+          <a:p>
+            <a:pPr indent="0" marL="0">
+              <a:buNone/>
+            </a:pPr>
+            <a:r>
+              <a:rPr lang="en-US" sz="1200" b="1" spc="300" kern="0" dirty="0">
+                <a:solidFill>
+                  <a:srgbClr val="2563EB"/>
+                </a:solidFill>
+                <a:latin typeface="Arial" pitchFamily="34" charset="0"/>
+                <a:ea typeface="Arial" pitchFamily="34" charset="-122"/>
+                <a:cs typeface="Arial" pitchFamily="34" charset="-120"/>
+              </a:rPr>
               <a:t>AFTER THIS DECK</a:t>
             </a:r>
             <a:endParaRPr lang="en-US" sz="1200" dirty="0"/>
@@ -2869,9 +3652,9 @@
 </p:sld>
 </file>
 
-<file path=ppt/slides/slide11.xml><?xml version="1.0" encoding="utf-8"?>
+<file path=ppt/slides/slide12.xml><?xml version="1.0" encoding="utf-8"?>
 <p:sld xmlns:a="http://schemas.openxmlformats.org/drawingml/2006/main" xmlns:r="http://schemas.openxmlformats.org/officeDocument/2006/relationships" xmlns:p="http://schemas.openxmlformats.org/presentationml/2006/main">
-  <p:cSld name="Slide 11">
+  <p:cSld name="Slide 12">
     <p:bg>
       <p:bgPr>
         <a:solidFill>
@@ -3810,7 +4593,7 @@
                 <a:ea typeface="Calibri" pitchFamily="34" charset="-122"/>
                 <a:cs typeface="Calibri" pitchFamily="34" charset="-120"/>
               </a:rPr>
-              <a:t>Surfaces from DSL — forms, tables, panels, actor, (soon) presence &amp; composer</a:t>
+              <a:t>Surfaces from DSL — forms, tables, panels, actor, presence &amp; composer</a:t>
             </a:r>
             <a:endParaRPr lang="en-US" sz="1150" dirty="0"/>
           </a:p>
@@ -5339,7 +6122,7 @@
                 <a:ea typeface="Arial" pitchFamily="34" charset="-122"/>
                 <a:cs typeface="Arial" pitchFamily="34" charset="-120"/>
               </a:rPr>
-              <a:t>02 · STATE MACHINE → DIAGRAM</a:t>
+              <a:t>01B · HOST COMPONENTS → THE DAY VIEW</a:t>
             </a:r>
             <a:endParaRPr lang="en-US" sz="1200" dirty="0"/>
           </a:p>
@@ -5378,7 +6161,7 @@
                 <a:ea typeface="Arial" pitchFamily="34" charset="-122"/>
                 <a:cs typeface="Arial" pitchFamily="34" charset="-120"/>
               </a:rPr>
-              <a:t>Four lines; the picture cannot drift</a:t>
+              <a:t>Chrome around the data, hosted</a:t>
             </a:r>
             <a:endParaRPr lang="en-US" sz="3000" dirty="0"/>
           </a:p>
@@ -5451,7 +6234,7 @@
                 <a:ea typeface="Courier New" pitchFamily="34" charset="-122"/>
                 <a:cs typeface="Courier New" pitchFamily="34" charset="-120"/>
               </a:rPr>
-              <a:t>lib/clinic_demo/scheduling/appointment.ex</a:t>
+              <a:t>lib/clinic_demo_web/live/day_live.ex</a:t>
             </a:r>
             <a:endParaRPr lang="en-US" sz="1000" dirty="0"/>
           </a:p>
@@ -5493,17 +6276,8 @@
                 <a:ea typeface="Courier New" pitchFamily="34" charset="-122"/>
                 <a:cs typeface="Courier New" pitchFamily="34" charset="-120"/>
               </a:rPr>
-              <a:t>extensions: [AshStateMachine]</a:t>
-            </a:r>
-            <a:endParaRPr lang="en-US" sz="1050" dirty="0"/>
-          </a:p>
-          <a:p>
-            <a:pPr indent="0" marL="0">
-              <a:lnSpc>
-                <a:spcPct val="104000"/>
-              </a:lnSpc>
-              <a:buNone/>
-            </a:pPr>
+              <a:t># not an a2ui surface — the NB layer</a:t>
+            </a:r>
             <a:endParaRPr lang="en-US" sz="1050" dirty="0"/>
           </a:p>
           <a:p>
@@ -5522,7 +6296,7 @@
                 <a:ea typeface="Courier New" pitchFamily="34" charset="-122"/>
                 <a:cs typeface="Courier New" pitchFamily="34" charset="-120"/>
               </a:rPr>
-              <a:t>state_machine do</a:t>
+              <a:t># (ash_a2ui's Lane D), themed by the</a:t>
             </a:r>
             <a:endParaRPr lang="en-US" sz="1050" dirty="0"/>
           </a:p>
@@ -5542,7 +6316,7 @@
                 <a:ea typeface="Courier New" pitchFamily="34" charset="-122"/>
                 <a:cs typeface="Courier New" pitchFamily="34" charset="-120"/>
               </a:rPr>
-              <a:t>  state_attribute(:status)</a:t>
+              <a:t># same --a2ui-* tokens, no overrides:</a:t>
             </a:r>
             <a:endParaRPr lang="en-US" sz="1050" dirty="0"/>
           </a:p>
@@ -5562,17 +6336,8 @@
                 <a:ea typeface="Courier New" pitchFamily="34" charset="-122"/>
                 <a:cs typeface="Courier New" pitchFamily="34" charset="-120"/>
               </a:rPr>
-              <a:t>  default_initial_state(:scheduled)</a:t>
-            </a:r>
-            <a:endParaRPr lang="en-US" sz="1050" dirty="0"/>
-          </a:p>
-          <a:p>
-            <a:pPr indent="0" marL="0">
-              <a:lnSpc>
-                <a:spcPct val="104000"/>
-              </a:lnSpc>
-              <a:buNone/>
-            </a:pPr>
+              <a:t>&lt;nb-calendar phx-hook="DayCalendar"</a:t>
+            </a:r>
             <a:endParaRPr lang="en-US" sz="1050" dirty="0"/>
           </a:p>
           <a:p>
@@ -5591,7 +6356,7 @@
                 <a:ea typeface="Courier New" pitchFamily="34" charset="-122"/>
                 <a:cs typeface="Courier New" pitchFamily="34" charset="-120"/>
               </a:rPr>
-              <a:t>  transitions do</a:t>
+              <a:t>  month={@month}</a:t>
             </a:r>
             <a:endParaRPr lang="en-US" sz="1050" dirty="0"/>
           </a:p>
@@ -5611,7 +6376,7 @@
                 <a:ea typeface="Courier New" pitchFamily="34" charset="-122"/>
                 <a:cs typeface="Courier New" pitchFamily="34" charset="-120"/>
               </a:rPr>
-              <a:t>    transition(:check_in,</a:t>
+              <a:t>  selected={Date.to_iso8601(@selected_day)}</a:t>
             </a:r>
             <a:endParaRPr lang="en-US" sz="1050" dirty="0"/>
           </a:p>
@@ -5631,8 +6396,17 @@
                 <a:ea typeface="Courier New" pitchFamily="34" charset="-122"/>
                 <a:cs typeface="Courier New" pitchFamily="34" charset="-120"/>
               </a:rPr>
-              <a:t>      from: :scheduled, to: :checked_in)</a:t>
-            </a:r>
+              <a:t>  items={@item_dates} /&gt;</a:t>
+            </a:r>
+            <a:endParaRPr lang="en-US" sz="1050" dirty="0"/>
+          </a:p>
+          <a:p>
+            <a:pPr indent="0" marL="0">
+              <a:lnSpc>
+                <a:spcPct val="104000"/>
+              </a:lnSpc>
+              <a:buNone/>
+            </a:pPr>
             <a:endParaRPr lang="en-US" sz="1050" dirty="0"/>
           </a:p>
           <a:p>
@@ -5651,7 +6425,7 @@
                 <a:ea typeface="Courier New" pitchFamily="34" charset="-122"/>
                 <a:cs typeface="Courier New" pitchFamily="34" charset="-120"/>
               </a:rPr>
-              <a:t>    transition(:complete,</a:t>
+              <a:t>&lt;nb-item phx-click="open_detail"</a:t>
             </a:r>
             <a:endParaRPr lang="en-US" sz="1050" dirty="0"/>
           </a:p>
@@ -5671,7 +6445,7 @@
                 <a:ea typeface="Courier New" pitchFamily="34" charset="-122"/>
                 <a:cs typeface="Courier New" pitchFamily="34" charset="-120"/>
               </a:rPr>
-              <a:t>      from: :checked_in, to: :completed)</a:t>
+              <a:t>  status={status_vocab(@appointment)}</a:t>
             </a:r>
             <a:endParaRPr lang="en-US" sz="1050" dirty="0"/>
           </a:p>
@@ -5691,7 +6465,7 @@
                 <a:ea typeface="Courier New" pitchFamily="34" charset="-122"/>
                 <a:cs typeface="Courier New" pitchFamily="34" charset="-120"/>
               </a:rPr>
-              <a:t>    transition(:cancel,</a:t>
+              <a:t>  label={"#{@appointment.patient_label}</a:t>
             </a:r>
             <a:endParaRPr lang="en-US" sz="1050" dirty="0"/>
           </a:p>
@@ -5711,7 +6485,7 @@
                 <a:ea typeface="Courier New" pitchFamily="34" charset="-122"/>
                 <a:cs typeface="Courier New" pitchFamily="34" charset="-120"/>
               </a:rPr>
-              <a:t>      from: [:scheduled, :checked_in],</a:t>
+              <a:t>          — #{@appointment.reason}"}</a:t>
             </a:r>
             <a:endParaRPr lang="en-US" sz="1050" dirty="0"/>
           </a:p>
@@ -5731,7 +6505,7 @@
                 <a:ea typeface="Courier New" pitchFamily="34" charset="-122"/>
                 <a:cs typeface="Courier New" pitchFamily="34" charset="-120"/>
               </a:rPr>
-              <a:t>      to: :cancelled)</a:t>
+              <a:t>  meta={time_range(@appointment)}</a:t>
             </a:r>
             <a:endParaRPr lang="en-US" sz="1050" dirty="0"/>
           </a:p>
@@ -5751,8 +6525,17 @@
                 <a:ea typeface="Courier New" pitchFamily="34" charset="-122"/>
                 <a:cs typeface="Courier New" pitchFamily="34" charset="-120"/>
               </a:rPr>
-              <a:t>    transition(:mark_no_show,</a:t>
-            </a:r>
+              <a:t>  selectable /&gt;</a:t>
+            </a:r>
+            <a:endParaRPr lang="en-US" sz="1050" dirty="0"/>
+          </a:p>
+          <a:p>
+            <a:pPr indent="0" marL="0">
+              <a:lnSpc>
+                <a:spcPct val="104000"/>
+              </a:lnSpc>
+              <a:buNone/>
+            </a:pPr>
             <a:endParaRPr lang="en-US" sz="1050" dirty="0"/>
           </a:p>
           <a:p>
@@ -5771,7 +6554,7 @@
                 <a:ea typeface="Courier New" pitchFamily="34" charset="-122"/>
                 <a:cs typeface="Courier New" pitchFamily="34" charset="-120"/>
               </a:rPr>
-              <a:t>      from: :scheduled, to: :no_show)</a:t>
+              <a:t>&lt;%!-- the day's tail folds natively --%&gt;</a:t>
             </a:r>
             <a:endParaRPr lang="en-US" sz="1050" dirty="0"/>
           </a:p>
@@ -5791,7 +6574,7 @@
                 <a:ea typeface="Courier New" pitchFamily="34" charset="-122"/>
                 <a:cs typeface="Courier New" pitchFamily="34" charset="-120"/>
               </a:rPr>
-              <a:t>  end</a:t>
+              <a:t>&lt;details :if={@earlier != []}&gt;</a:t>
             </a:r>
             <a:endParaRPr lang="en-US" sz="1050" dirty="0"/>
           </a:p>
@@ -5811,7 +6594,87 @@
                 <a:ea typeface="Courier New" pitchFamily="34" charset="-122"/>
                 <a:cs typeface="Courier New" pitchFamily="34" charset="-120"/>
               </a:rPr>
-              <a:t>end</a:t>
+              <a:t>  &lt;summary&gt;</a:t>
+            </a:r>
+            <a:endParaRPr lang="en-US" sz="1050" dirty="0"/>
+          </a:p>
+          <a:p>
+            <a:pPr indent="0" marL="0">
+              <a:lnSpc>
+                <a:spcPct val="104000"/>
+              </a:lnSpc>
+              <a:buNone/>
+            </a:pPr>
+            <a:r>
+              <a:rPr lang="en-US" sz="1050" dirty="0">
+                <a:solidFill>
+                  <a:srgbClr val="141414"/>
+                </a:solidFill>
+                <a:latin typeface="Courier New" pitchFamily="34" charset="0"/>
+                <a:ea typeface="Courier New" pitchFamily="34" charset="-122"/>
+                <a:cs typeface="Courier New" pitchFamily="34" charset="-120"/>
+              </a:rPr>
+              <a:t>    Earlier today ({length(@earlier)})</a:t>
+            </a:r>
+            <a:endParaRPr lang="en-US" sz="1050" dirty="0"/>
+          </a:p>
+          <a:p>
+            <a:pPr indent="0" marL="0">
+              <a:lnSpc>
+                <a:spcPct val="104000"/>
+              </a:lnSpc>
+              <a:buNone/>
+            </a:pPr>
+            <a:r>
+              <a:rPr lang="en-US" sz="1050" dirty="0">
+                <a:solidFill>
+                  <a:srgbClr val="141414"/>
+                </a:solidFill>
+                <a:latin typeface="Courier New" pitchFamily="34" charset="0"/>
+                <a:ea typeface="Courier New" pitchFamily="34" charset="-122"/>
+                <a:cs typeface="Courier New" pitchFamily="34" charset="-120"/>
+              </a:rPr>
+              <a:t>  &lt;/summary&gt;</a:t>
+            </a:r>
+            <a:endParaRPr lang="en-US" sz="1050" dirty="0"/>
+          </a:p>
+          <a:p>
+            <a:pPr indent="0" marL="0">
+              <a:lnSpc>
+                <a:spcPct val="104000"/>
+              </a:lnSpc>
+              <a:buNone/>
+            </a:pPr>
+            <a:r>
+              <a:rPr lang="en-US" sz="1050" dirty="0">
+                <a:solidFill>
+                  <a:srgbClr val="141414"/>
+                </a:solidFill>
+                <a:latin typeface="Courier New" pitchFamily="34" charset="0"/>
+                <a:ea typeface="Courier New" pitchFamily="34" charset="-122"/>
+                <a:cs typeface="Courier New" pitchFamily="34" charset="-120"/>
+              </a:rPr>
+              <a:t>  ...</a:t>
+            </a:r>
+            <a:endParaRPr lang="en-US" sz="1050" dirty="0"/>
+          </a:p>
+          <a:p>
+            <a:pPr indent="0" marL="0">
+              <a:lnSpc>
+                <a:spcPct val="104000"/>
+              </a:lnSpc>
+              <a:buNone/>
+            </a:pPr>
+            <a:r>
+              <a:rPr lang="en-US" sz="1050" dirty="0">
+                <a:solidFill>
+                  <a:srgbClr val="141414"/>
+                </a:solidFill>
+                <a:latin typeface="Courier New" pitchFamily="34" charset="0"/>
+                <a:ea typeface="Courier New" pitchFamily="34" charset="-122"/>
+                <a:cs typeface="Courier New" pitchFamily="34" charset="-120"/>
+              </a:rPr>
+              <a:t>&lt;/details&gt;</a:t>
             </a:r>
             <a:endParaRPr lang="en-US" sz="1050" dirty="0"/>
           </a:p>
@@ -5853,7 +6716,7 @@
       </p:sp>
       <p:pic>
         <p:nvPicPr>
-          <p:cNvPr id="8" name="Image 0" descr="/tmp/opencode/deck-shots/operator.png">    </p:cNvPr>
+          <p:cNvPr id="8" name="Image 0" descr="/tmp/opencode/deck-shots/day.png">    </p:cNvPr>
           <p:cNvPicPr>
             <a:picLocks noChangeAspect="1"/>
           </p:cNvPicPr>
@@ -5884,7 +6747,7 @@
         <p:spPr>
           <a:xfrm>
             <a:off x="6611112" y="4526280"/>
-            <a:ext cx="1192378" cy="310896"/>
+            <a:ext cx="2991917" cy="310896"/>
           </a:xfrm>
           <a:prstGeom prst="roundRect">
             <a:avLst>
@@ -5918,7 +6781,7 @@
         <p:spPr>
           <a:xfrm>
             <a:off x="6611112" y="4526280"/>
-            <a:ext cx="1192378" cy="310896"/>
+            <a:ext cx="2991917" cy="310896"/>
           </a:xfrm>
           <a:prstGeom prst="rect">
             <a:avLst/>
@@ -5942,7 +6805,7 @@
                 <a:ea typeface="Arial" pitchFamily="34" charset="-122"/>
                 <a:cs typeface="Arial" pitchFamily="34" charset="-120"/>
               </a:rPr>
-              <a:t>operator hub</a:t>
+              <a:t>live at /day — earlier half unfolded</a:t>
             </a:r>
             <a:endParaRPr lang="en-US" sz="1100" dirty="0"/>
           </a:p>
@@ -5981,7 +6844,7 @@
                 <a:ea typeface="Calibri" pitchFamily="34" charset="-122"/>
                 <a:cs typeface="Calibri" pitchFamily="34" charset="-120"/>
               </a:rPr>
-              <a:t>The operator hub renders this declaration as a Mermaid diagram — derived, never drawn by hand. Illegal transitions are refused by name: “from scheduled to completed” is what the error says.</a:t>
+              <a:t>The Day view is chrome around the data, so it hosts the NB component layer: a month grid, status-dotted visit rows, a read-only nb-sheet. The day's tail folds into a native &lt;details&gt; — and the seeds plant one earlier-today visit, so the fold always has a real past item to collapse.</a:t>
             </a:r>
             <a:endParaRPr lang="en-US" sz="1250" dirty="0"/>
           </a:p>
@@ -6052,7 +6915,7 @@
                 <a:ea typeface="Arial" pitchFamily="34" charset="-122"/>
                 <a:cs typeface="Arial" pitchFamily="34" charset="-120"/>
               </a:rPr>
-              <a:t>03 · POLICY → AUTHORIZATION</a:t>
+              <a:t>02 · STATE MACHINE → DIAGRAM</a:t>
             </a:r>
             <a:endParaRPr lang="en-US" sz="1200" dirty="0"/>
           </a:p>
@@ -6091,7 +6954,7 @@
                 <a:ea typeface="Arial" pitchFamily="34" charset="-122"/>
                 <a:cs typeface="Arial" pitchFamily="34" charset="-120"/>
               </a:rPr>
-              <a:t>Two policies gate the whole app</a:t>
+              <a:t>Four lines; the picture cannot drift</a:t>
             </a:r>
             <a:endParaRPr lang="en-US" sz="3000" dirty="0"/>
           </a:p>
@@ -6206,8 +7069,17 @@
                 <a:ea typeface="Courier New" pitchFamily="34" charset="-122"/>
                 <a:cs typeface="Courier New" pitchFamily="34" charset="-120"/>
               </a:rPr>
-              <a:t>policies do</a:t>
-            </a:r>
+              <a:t>extensions: [AshStateMachine]</a:t>
+            </a:r>
+            <a:endParaRPr lang="en-US" sz="1050" dirty="0"/>
+          </a:p>
+          <a:p>
+            <a:pPr indent="0" marL="0">
+              <a:lnSpc>
+                <a:spcPct val="104000"/>
+              </a:lnSpc>
+              <a:buNone/>
+            </a:pPr>
             <a:endParaRPr lang="en-US" sz="1050" dirty="0"/>
           </a:p>
           <a:p>
@@ -6226,7 +7098,7 @@
                 <a:ea typeface="Courier New" pitchFamily="34" charset="-122"/>
                 <a:cs typeface="Courier New" pitchFamily="34" charset="-120"/>
               </a:rPr>
-              <a:t>  policy action_type(:read) do</a:t>
+              <a:t>state_machine do</a:t>
             </a:r>
             <a:endParaRPr lang="en-US" sz="1050" dirty="0"/>
           </a:p>
@@ -6246,7 +7118,7 @@
                 <a:ea typeface="Courier New" pitchFamily="34" charset="-122"/>
                 <a:cs typeface="Courier New" pitchFamily="34" charset="-120"/>
               </a:rPr>
-              <a:t>    authorize_if always()</a:t>
+              <a:t>  state_attribute(:status)</a:t>
             </a:r>
             <a:endParaRPr lang="en-US" sz="1050" dirty="0"/>
           </a:p>
@@ -6266,6 +7138,235 @@
                 <a:ea typeface="Courier New" pitchFamily="34" charset="-122"/>
                 <a:cs typeface="Courier New" pitchFamily="34" charset="-120"/>
               </a:rPr>
+              <a:t>  default_initial_state(:scheduled)</a:t>
+            </a:r>
+            <a:endParaRPr lang="en-US" sz="1050" dirty="0"/>
+          </a:p>
+          <a:p>
+            <a:pPr indent="0" marL="0">
+              <a:lnSpc>
+                <a:spcPct val="104000"/>
+              </a:lnSpc>
+              <a:buNone/>
+            </a:pPr>
+            <a:endParaRPr lang="en-US" sz="1050" dirty="0"/>
+          </a:p>
+          <a:p>
+            <a:pPr indent="0" marL="0">
+              <a:lnSpc>
+                <a:spcPct val="104000"/>
+              </a:lnSpc>
+              <a:buNone/>
+            </a:pPr>
+            <a:r>
+              <a:rPr lang="en-US" sz="1050" dirty="0">
+                <a:solidFill>
+                  <a:srgbClr val="141414"/>
+                </a:solidFill>
+                <a:latin typeface="Courier New" pitchFamily="34" charset="0"/>
+                <a:ea typeface="Courier New" pitchFamily="34" charset="-122"/>
+                <a:cs typeface="Courier New" pitchFamily="34" charset="-120"/>
+              </a:rPr>
+              <a:t>  transitions do</a:t>
+            </a:r>
+            <a:endParaRPr lang="en-US" sz="1050" dirty="0"/>
+          </a:p>
+          <a:p>
+            <a:pPr indent="0" marL="0">
+              <a:lnSpc>
+                <a:spcPct val="104000"/>
+              </a:lnSpc>
+              <a:buNone/>
+            </a:pPr>
+            <a:r>
+              <a:rPr lang="en-US" sz="1050" dirty="0">
+                <a:solidFill>
+                  <a:srgbClr val="141414"/>
+                </a:solidFill>
+                <a:latin typeface="Courier New" pitchFamily="34" charset="0"/>
+                <a:ea typeface="Courier New" pitchFamily="34" charset="-122"/>
+                <a:cs typeface="Courier New" pitchFamily="34" charset="-120"/>
+              </a:rPr>
+              <a:t>    transition(:check_in,</a:t>
+            </a:r>
+            <a:endParaRPr lang="en-US" sz="1050" dirty="0"/>
+          </a:p>
+          <a:p>
+            <a:pPr indent="0" marL="0">
+              <a:lnSpc>
+                <a:spcPct val="104000"/>
+              </a:lnSpc>
+              <a:buNone/>
+            </a:pPr>
+            <a:r>
+              <a:rPr lang="en-US" sz="1050" dirty="0">
+                <a:solidFill>
+                  <a:srgbClr val="141414"/>
+                </a:solidFill>
+                <a:latin typeface="Courier New" pitchFamily="34" charset="0"/>
+                <a:ea typeface="Courier New" pitchFamily="34" charset="-122"/>
+                <a:cs typeface="Courier New" pitchFamily="34" charset="-120"/>
+              </a:rPr>
+              <a:t>      from: :scheduled, to: :checked_in)</a:t>
+            </a:r>
+            <a:endParaRPr lang="en-US" sz="1050" dirty="0"/>
+          </a:p>
+          <a:p>
+            <a:pPr indent="0" marL="0">
+              <a:lnSpc>
+                <a:spcPct val="104000"/>
+              </a:lnSpc>
+              <a:buNone/>
+            </a:pPr>
+            <a:r>
+              <a:rPr lang="en-US" sz="1050" dirty="0">
+                <a:solidFill>
+                  <a:srgbClr val="141414"/>
+                </a:solidFill>
+                <a:latin typeface="Courier New" pitchFamily="34" charset="0"/>
+                <a:ea typeface="Courier New" pitchFamily="34" charset="-122"/>
+                <a:cs typeface="Courier New" pitchFamily="34" charset="-120"/>
+              </a:rPr>
+              <a:t>    transition(:complete,</a:t>
+            </a:r>
+            <a:endParaRPr lang="en-US" sz="1050" dirty="0"/>
+          </a:p>
+          <a:p>
+            <a:pPr indent="0" marL="0">
+              <a:lnSpc>
+                <a:spcPct val="104000"/>
+              </a:lnSpc>
+              <a:buNone/>
+            </a:pPr>
+            <a:r>
+              <a:rPr lang="en-US" sz="1050" dirty="0">
+                <a:solidFill>
+                  <a:srgbClr val="141414"/>
+                </a:solidFill>
+                <a:latin typeface="Courier New" pitchFamily="34" charset="0"/>
+                <a:ea typeface="Courier New" pitchFamily="34" charset="-122"/>
+                <a:cs typeface="Courier New" pitchFamily="34" charset="-120"/>
+              </a:rPr>
+              <a:t>      from: :checked_in, to: :completed)</a:t>
+            </a:r>
+            <a:endParaRPr lang="en-US" sz="1050" dirty="0"/>
+          </a:p>
+          <a:p>
+            <a:pPr indent="0" marL="0">
+              <a:lnSpc>
+                <a:spcPct val="104000"/>
+              </a:lnSpc>
+              <a:buNone/>
+            </a:pPr>
+            <a:r>
+              <a:rPr lang="en-US" sz="1050" dirty="0">
+                <a:solidFill>
+                  <a:srgbClr val="141414"/>
+                </a:solidFill>
+                <a:latin typeface="Courier New" pitchFamily="34" charset="0"/>
+                <a:ea typeface="Courier New" pitchFamily="34" charset="-122"/>
+                <a:cs typeface="Courier New" pitchFamily="34" charset="-120"/>
+              </a:rPr>
+              <a:t>    transition(:cancel,</a:t>
+            </a:r>
+            <a:endParaRPr lang="en-US" sz="1050" dirty="0"/>
+          </a:p>
+          <a:p>
+            <a:pPr indent="0" marL="0">
+              <a:lnSpc>
+                <a:spcPct val="104000"/>
+              </a:lnSpc>
+              <a:buNone/>
+            </a:pPr>
+            <a:r>
+              <a:rPr lang="en-US" sz="1050" dirty="0">
+                <a:solidFill>
+                  <a:srgbClr val="141414"/>
+                </a:solidFill>
+                <a:latin typeface="Courier New" pitchFamily="34" charset="0"/>
+                <a:ea typeface="Courier New" pitchFamily="34" charset="-122"/>
+                <a:cs typeface="Courier New" pitchFamily="34" charset="-120"/>
+              </a:rPr>
+              <a:t>      from: [:scheduled, :checked_in],</a:t>
+            </a:r>
+            <a:endParaRPr lang="en-US" sz="1050" dirty="0"/>
+          </a:p>
+          <a:p>
+            <a:pPr indent="0" marL="0">
+              <a:lnSpc>
+                <a:spcPct val="104000"/>
+              </a:lnSpc>
+              <a:buNone/>
+            </a:pPr>
+            <a:r>
+              <a:rPr lang="en-US" sz="1050" dirty="0">
+                <a:solidFill>
+                  <a:srgbClr val="141414"/>
+                </a:solidFill>
+                <a:latin typeface="Courier New" pitchFamily="34" charset="0"/>
+                <a:ea typeface="Courier New" pitchFamily="34" charset="-122"/>
+                <a:cs typeface="Courier New" pitchFamily="34" charset="-120"/>
+              </a:rPr>
+              <a:t>      to: :cancelled)</a:t>
+            </a:r>
+            <a:endParaRPr lang="en-US" sz="1050" dirty="0"/>
+          </a:p>
+          <a:p>
+            <a:pPr indent="0" marL="0">
+              <a:lnSpc>
+                <a:spcPct val="104000"/>
+              </a:lnSpc>
+              <a:buNone/>
+            </a:pPr>
+            <a:r>
+              <a:rPr lang="en-US" sz="1050" dirty="0">
+                <a:solidFill>
+                  <a:srgbClr val="141414"/>
+                </a:solidFill>
+                <a:latin typeface="Courier New" pitchFamily="34" charset="0"/>
+                <a:ea typeface="Courier New" pitchFamily="34" charset="-122"/>
+                <a:cs typeface="Courier New" pitchFamily="34" charset="-120"/>
+              </a:rPr>
+              <a:t>    transition(:mark_no_show,</a:t>
+            </a:r>
+            <a:endParaRPr lang="en-US" sz="1050" dirty="0"/>
+          </a:p>
+          <a:p>
+            <a:pPr indent="0" marL="0">
+              <a:lnSpc>
+                <a:spcPct val="104000"/>
+              </a:lnSpc>
+              <a:buNone/>
+            </a:pPr>
+            <a:r>
+              <a:rPr lang="en-US" sz="1050" dirty="0">
+                <a:solidFill>
+                  <a:srgbClr val="141414"/>
+                </a:solidFill>
+                <a:latin typeface="Courier New" pitchFamily="34" charset="0"/>
+                <a:ea typeface="Courier New" pitchFamily="34" charset="-122"/>
+                <a:cs typeface="Courier New" pitchFamily="34" charset="-120"/>
+              </a:rPr>
+              <a:t>      from: :scheduled, to: :no_show)</a:t>
+            </a:r>
+            <a:endParaRPr lang="en-US" sz="1050" dirty="0"/>
+          </a:p>
+          <a:p>
+            <a:pPr indent="0" marL="0">
+              <a:lnSpc>
+                <a:spcPct val="104000"/>
+              </a:lnSpc>
+              <a:buNone/>
+            </a:pPr>
+            <a:r>
+              <a:rPr lang="en-US" sz="1050" dirty="0">
+                <a:solidFill>
+                  <a:srgbClr val="141414"/>
+                </a:solidFill>
+                <a:latin typeface="Courier New" pitchFamily="34" charset="0"/>
+                <a:ea typeface="Courier New" pitchFamily="34" charset="-122"/>
+                <a:cs typeface="Courier New" pitchFamily="34" charset="-120"/>
+              </a:rPr>
               <a:t>  end</a:t>
             </a:r>
             <a:endParaRPr lang="en-US" sz="1050" dirty="0"/>
@@ -6277,15 +7378,6 @@
               </a:lnSpc>
               <a:buNone/>
             </a:pPr>
-            <a:endParaRPr lang="en-US" sz="1050" dirty="0"/>
-          </a:p>
-          <a:p>
-            <a:pPr indent="0" marL="0">
-              <a:lnSpc>
-                <a:spcPct val="104000"/>
-              </a:lnSpc>
-              <a:buNone/>
-            </a:pPr>
             <a:r>
               <a:rPr lang="en-US" sz="1050" dirty="0">
                 <a:solidFill>
@@ -6295,156 +7387,7 @@
                 <a:ea typeface="Courier New" pitchFamily="34" charset="-122"/>
                 <a:cs typeface="Courier New" pitchFamily="34" charset="-120"/>
               </a:rPr>
-              <a:t>  policy action_type([</a:t>
-            </a:r>
-            <a:endParaRPr lang="en-US" sz="1050" dirty="0"/>
-          </a:p>
-          <a:p>
-            <a:pPr indent="0" marL="0">
-              <a:lnSpc>
-                <a:spcPct val="104000"/>
-              </a:lnSpc>
-              <a:buNone/>
-            </a:pPr>
-            <a:r>
-              <a:rPr lang="en-US" sz="1050" dirty="0">
-                <a:solidFill>
-                  <a:srgbClr val="141414"/>
-                </a:solidFill>
-                <a:latin typeface="Courier New" pitchFamily="34" charset="0"/>
-                <a:ea typeface="Courier New" pitchFamily="34" charset="-122"/>
-                <a:cs typeface="Courier New" pitchFamily="34" charset="-120"/>
-              </a:rPr>
-              <a:t>      :create, :update, :destroy]) do</a:t>
-            </a:r>
-            <a:endParaRPr lang="en-US" sz="1050" dirty="0"/>
-          </a:p>
-          <a:p>
-            <a:pPr indent="0" marL="0">
-              <a:lnSpc>
-                <a:spcPct val="104000"/>
-              </a:lnSpc>
-              <a:buNone/>
-            </a:pPr>
-            <a:r>
-              <a:rPr lang="en-US" sz="1050" dirty="0">
-                <a:solidFill>
-                  <a:srgbClr val="141414"/>
-                </a:solidFill>
-                <a:latin typeface="Courier New" pitchFamily="34" charset="0"/>
-                <a:ea typeface="Courier New" pitchFamily="34" charset="-122"/>
-                <a:cs typeface="Courier New" pitchFamily="34" charset="-120"/>
-              </a:rPr>
-              <a:t>    authorize_if actor_present()</a:t>
-            </a:r>
-            <a:endParaRPr lang="en-US" sz="1050" dirty="0"/>
-          </a:p>
-          <a:p>
-            <a:pPr indent="0" marL="0">
-              <a:lnSpc>
-                <a:spcPct val="104000"/>
-              </a:lnSpc>
-              <a:buNone/>
-            </a:pPr>
-            <a:r>
-              <a:rPr lang="en-US" sz="1050" dirty="0">
-                <a:solidFill>
-                  <a:srgbClr val="141414"/>
-                </a:solidFill>
-                <a:latin typeface="Courier New" pitchFamily="34" charset="0"/>
-                <a:ea typeface="Courier New" pitchFamily="34" charset="-122"/>
-                <a:cs typeface="Courier New" pitchFamily="34" charset="-120"/>
-              </a:rPr>
-              <a:t>  end</a:t>
-            </a:r>
-            <a:endParaRPr lang="en-US" sz="1050" dirty="0"/>
-          </a:p>
-          <a:p>
-            <a:pPr indent="0" marL="0">
-              <a:lnSpc>
-                <a:spcPct val="104000"/>
-              </a:lnSpc>
-              <a:buNone/>
-            </a:pPr>
-            <a:r>
-              <a:rPr lang="en-US" sz="1050" dirty="0">
-                <a:solidFill>
-                  <a:srgbClr val="141414"/>
-                </a:solidFill>
-                <a:latin typeface="Courier New" pitchFamily="34" charset="0"/>
-                <a:ea typeface="Courier New" pitchFamily="34" charset="-122"/>
-                <a:cs typeface="Courier New" pitchFamily="34" charset="-120"/>
-              </a:rPr>
               <a:t>end</a:t>
-            </a:r>
-            <a:endParaRPr lang="en-US" sz="1050" dirty="0"/>
-          </a:p>
-          <a:p>
-            <a:pPr indent="0" marL="0">
-              <a:lnSpc>
-                <a:spcPct val="104000"/>
-              </a:lnSpc>
-              <a:buNone/>
-            </a:pPr>
-            <a:endParaRPr lang="en-US" sz="1050" dirty="0"/>
-          </a:p>
-          <a:p>
-            <a:pPr indent="0" marL="0">
-              <a:lnSpc>
-                <a:spcPct val="104000"/>
-              </a:lnSpc>
-              <a:buNone/>
-            </a:pPr>
-            <a:r>
-              <a:rPr lang="en-US" sz="1050" dirty="0">
-                <a:solidFill>
-                  <a:srgbClr val="141414"/>
-                </a:solidFill>
-                <a:latin typeface="Courier New" pitchFamily="34" charset="0"/>
-                <a:ea typeface="Courier New" pitchFamily="34" charset="-122"/>
-                <a:cs typeface="Courier New" pitchFamily="34" charset="-120"/>
-              </a:rPr>
-              <a:t># config :ash_a2ui, actor: [</a:t>
-            </a:r>
-            <a:endParaRPr lang="en-US" sz="1050" dirty="0"/>
-          </a:p>
-          <a:p>
-            <a:pPr indent="0" marL="0">
-              <a:lnSpc>
-                <a:spcPct val="104000"/>
-              </a:lnSpc>
-              <a:buNone/>
-            </a:pPr>
-            <a:r>
-              <a:rPr lang="en-US" sz="1050" dirty="0">
-                <a:solidFill>
-                  <a:srgbClr val="141414"/>
-                </a:solidFill>
-                <a:latin typeface="Courier New" pitchFamily="34" charset="0"/>
-                <a:ea typeface="Courier New" pitchFamily="34" charset="-122"/>
-                <a:cs typeface="Courier New" pitchFamily="34" charset="-120"/>
-              </a:rPr>
-              <a:t>#   resource: ClinicDemo.Scheduling.Clinician,</a:t>
-            </a:r>
-            <a:endParaRPr lang="en-US" sz="1050" dirty="0"/>
-          </a:p>
-          <a:p>
-            <a:pPr indent="0" marL="0">
-              <a:lnSpc>
-                <a:spcPct val="104000"/>
-              </a:lnSpc>
-              <a:buNone/>
-            </a:pPr>
-            <a:r>
-              <a:rPr lang="en-US" sz="1050" dirty="0">
-                <a:solidFill>
-                  <a:srgbClr val="141414"/>
-                </a:solidFill>
-                <a:latin typeface="Courier New" pitchFamily="34" charset="0"/>
-                <a:ea typeface="Courier New" pitchFamily="34" charset="-122"/>
-                <a:cs typeface="Courier New" pitchFamily="34" charset="-120"/>
-              </a:rPr>
-              <a:t>#   label: :full_name]</a:t>
             </a:r>
             <a:endParaRPr lang="en-US" sz="1050" dirty="0"/>
           </a:p>
@@ -6486,7 +7429,7 @@
       </p:sp>
       <p:pic>
         <p:nvPicPr>
-          <p:cNvPr id="8" name="Image 0" descr="/tmp/opencode/deck-shots/board.png">    </p:cNvPr>
+          <p:cNvPr id="8" name="Image 0" descr="/tmp/opencode/deck-shots/operator.png">    </p:cNvPr>
           <p:cNvPicPr>
             <a:picLocks noChangeAspect="1"/>
           </p:cNvPicPr>
@@ -6517,7 +7460,7 @@
         <p:spPr>
           <a:xfrm>
             <a:off x="6611112" y="4526280"/>
-            <a:ext cx="967435" cy="310896"/>
+            <a:ext cx="1192378" cy="310896"/>
           </a:xfrm>
           <a:prstGeom prst="roundRect">
             <a:avLst>
@@ -6551,7 +7494,7 @@
         <p:spPr>
           <a:xfrm>
             <a:off x="6611112" y="4526280"/>
-            <a:ext cx="967435" cy="310896"/>
+            <a:ext cx="1192378" cy="310896"/>
           </a:xfrm>
           <a:prstGeom prst="rect">
             <a:avLst/>
@@ -6575,7 +7518,7 @@
                 <a:ea typeface="Arial" pitchFamily="34" charset="-122"/>
                 <a:cs typeface="Arial" pitchFamily="34" charset="-120"/>
               </a:rPr>
-              <a:t>the board</a:t>
+              <a:t>operator hub</a:t>
             </a:r>
             <a:endParaRPr lang="en-US" sz="1100" dirty="0"/>
           </a:p>
@@ -6614,7 +7557,7 @@
                 <a:ea typeface="Calibri" pitchFamily="34" charset="-122"/>
                 <a:cs typeface="Calibri" pitchFamily="34" charset="-120"/>
               </a:rPr>
-              <a:t>Without a clinician picked at /acting-as, every write is refused — the board leads with the banner. The same declaration answers “why forbidden?” per policy, for agents and auditors alike.</a:t>
+              <a:t>The operator hub renders this declaration as a Mermaid diagram — derived, never drawn by hand. Illegal transitions are refused by name: “from scheduled to completed” is what the error says.</a:t>
             </a:r>
             <a:endParaRPr lang="en-US" sz="1250" dirty="0"/>
           </a:p>
@@ -6685,7 +7628,7 @@
                 <a:ea typeface="Arial" pitchFamily="34" charset="-122"/>
                 <a:cs typeface="Arial" pitchFamily="34" charset="-120"/>
               </a:rPr>
-              <a:t>04 · RULES → GUARD</a:t>
+              <a:t>03 · POLICY → AUTHORIZATION</a:t>
             </a:r>
             <a:endParaRPr lang="en-US" sz="1200" dirty="0"/>
           </a:p>
@@ -6724,7 +7667,7 @@
                 <a:ea typeface="Arial" pitchFamily="34" charset="-122"/>
                 <a:cs typeface="Arial" pitchFamily="34" charset="-120"/>
               </a:rPr>
-              <a:t>The rulebook is data, not code</a:t>
+              <a:t>Two policies gate the whole app</a:t>
             </a:r>
             <a:endParaRPr lang="en-US" sz="3000" dirty="0"/>
           </a:p>
@@ -6797,7 +7740,7 @@
                 <a:ea typeface="Courier New" pitchFamily="34" charset="-122"/>
                 <a:cs typeface="Courier New" pitchFamily="34" charset="-120"/>
               </a:rPr>
-              <a:t>lib/clinic_demo/compliance/appointment_rules.ex</a:t>
+              <a:t>lib/clinic_demo/scheduling/appointment.ex</a:t>
             </a:r>
             <a:endParaRPr lang="en-US" sz="1000" dirty="0"/>
           </a:p>
@@ -6839,17 +7782,8 @@
                 <a:ea typeface="Courier New" pitchFamily="34" charset="-122"/>
                 <a:cs typeface="Courier New" pitchFamily="34" charset="-120"/>
               </a:rPr>
-              <a:t>use AshRules</a:t>
-            </a:r>
-            <a:endParaRPr lang="en-US" sz="1050" dirty="0"/>
-          </a:p>
-          <a:p>
-            <a:pPr indent="0" marL="0">
-              <a:lnSpc>
-                <a:spcPct val="104000"/>
-              </a:lnSpc>
-              <a:buNone/>
-            </a:pPr>
+              <a:t>policies do</a:t>
+            </a:r>
             <a:endParaRPr lang="en-US" sz="1050" dirty="0"/>
           </a:p>
           <a:p>
@@ -6868,7 +7802,7 @@
                 <a:ea typeface="Courier New" pitchFamily="34" charset="-122"/>
                 <a:cs typeface="Courier New" pitchFamily="34" charset="-120"/>
               </a:rPr>
-              <a:t>rule "check-in requires a recorded weight",</a:t>
+              <a:t>  policy action_type(:read) do</a:t>
             </a:r>
             <a:endParaRPr lang="en-US" sz="1050" dirty="0"/>
           </a:p>
@@ -6888,7 +7822,7 @@
                 <a:ea typeface="Courier New" pitchFamily="34" charset="-122"/>
                 <a:cs typeface="Courier New" pitchFamily="34" charset="-120"/>
               </a:rPr>
-              <a:t>  id: "appt.checkin_requires_weight",</a:t>
+              <a:t>    authorize_if always()</a:t>
             </a:r>
             <a:endParaRPr lang="en-US" sz="1050" dirty="0"/>
           </a:p>
@@ -6908,8 +7842,17 @@
                 <a:ea typeface="Courier New" pitchFamily="34" charset="-122"/>
                 <a:cs typeface="Courier New" pitchFamily="34" charset="-120"/>
               </a:rPr>
-              <a:t>  severity: :high do</a:t>
-            </a:r>
+              <a:t>  end</a:t>
+            </a:r>
+            <a:endParaRPr lang="en-US" sz="1050" dirty="0"/>
+          </a:p>
+          <a:p>
+            <a:pPr indent="0" marL="0">
+              <a:lnSpc>
+                <a:spcPct val="104000"/>
+              </a:lnSpc>
+              <a:buNone/>
+            </a:pPr>
             <a:endParaRPr lang="en-US" sz="1050" dirty="0"/>
           </a:p>
           <a:p>
@@ -6928,7 +7871,7 @@
                 <a:ea typeface="Courier New" pitchFamily="34" charset="-122"/>
                 <a:cs typeface="Courier New" pitchFamily="34" charset="-120"/>
               </a:rPr>
-              <a:t>  when_requires(</a:t>
+              <a:t>  policy action_type([</a:t>
             </a:r>
             <a:endParaRPr lang="en-US" sz="1050" dirty="0"/>
           </a:p>
@@ -6948,7 +7891,7 @@
                 <a:ea typeface="Courier New" pitchFamily="34" charset="-122"/>
                 <a:cs typeface="Courier New" pitchFamily="34" charset="-120"/>
               </a:rPr>
-              <a:t>    has(:appointment, :transition_to,</a:t>
+              <a:t>      :create, :update, :destroy]) do</a:t>
             </a:r>
             <a:endParaRPr lang="en-US" sz="1050" dirty="0"/>
           </a:p>
@@ -6968,7 +7911,7 @@
                 <a:ea typeface="Courier New" pitchFamily="34" charset="-122"/>
                 <a:cs typeface="Courier New" pitchFamily="34" charset="-120"/>
               </a:rPr>
-              <a:t>        :checked_in))</a:t>
+              <a:t>    authorize_if actor_present()</a:t>
             </a:r>
             <a:endParaRPr lang="en-US" sz="1050" dirty="0"/>
           </a:p>
@@ -6988,7 +7931,7 @@
                 <a:ea typeface="Courier New" pitchFamily="34" charset="-122"/>
                 <a:cs typeface="Courier New" pitchFamily="34" charset="-120"/>
               </a:rPr>
-              <a:t>  fails_when(</a:t>
+              <a:t>  end</a:t>
             </a:r>
             <a:endParaRPr lang="en-US" sz="1050" dirty="0"/>
           </a:p>
@@ -7008,8 +7951,17 @@
                 <a:ea typeface="Courier New" pitchFamily="34" charset="-122"/>
                 <a:cs typeface="Courier New" pitchFamily="34" charset="-120"/>
               </a:rPr>
-              <a:t>    neg(:appointment,</a:t>
-            </a:r>
+              <a:t>end</a:t>
+            </a:r>
+            <a:endParaRPr lang="en-US" sz="1050" dirty="0"/>
+          </a:p>
+          <a:p>
+            <a:pPr indent="0" marL="0">
+              <a:lnSpc>
+                <a:spcPct val="104000"/>
+              </a:lnSpc>
+              <a:buNone/>
+            </a:pPr>
             <a:endParaRPr lang="en-US" sz="1050" dirty="0"/>
           </a:p>
           <a:p>
@@ -7028,7 +7980,7 @@
                 <a:ea typeface="Courier New" pitchFamily="34" charset="-122"/>
                 <a:cs typeface="Courier New" pitchFamily="34" charset="-120"/>
               </a:rPr>
-              <a:t>        :patient_weight_recorded, true))</a:t>
+              <a:t># config :ash_a2ui, actor: [</a:t>
             </a:r>
             <a:endParaRPr lang="en-US" sz="1050" dirty="0"/>
           </a:p>
@@ -7048,7 +8000,7 @@
                 <a:ea typeface="Courier New" pitchFamily="34" charset="-122"/>
                 <a:cs typeface="Courier New" pitchFamily="34" charset="-120"/>
               </a:rPr>
-              <a:t>  outcome(:noncompliant,</a:t>
+              <a:t>#   resource: ClinicDemo.Scheduling.Clinician,</a:t>
             </a:r>
             <a:endParaRPr lang="en-US" sz="1050" dirty="0"/>
           </a:p>
@@ -7068,116 +8020,7 @@
                 <a:ea typeface="Courier New" pitchFamily="34" charset="-122"/>
                 <a:cs typeface="Courier New" pitchFamily="34" charset="-120"/>
               </a:rPr>
-              <a:t>    gap: "record the patient's weight</a:t>
-            </a:r>
-            <a:endParaRPr lang="en-US" sz="1050" dirty="0"/>
-          </a:p>
-          <a:p>
-            <a:pPr indent="0" marL="0">
-              <a:lnSpc>
-                <a:spcPct val="104000"/>
-              </a:lnSpc>
-              <a:buNone/>
-            </a:pPr>
-            <a:r>
-              <a:rPr lang="en-US" sz="1050" dirty="0">
-                <a:solidFill>
-                  <a:srgbClr val="141414"/>
-                </a:solidFill>
-                <a:latin typeface="Courier New" pitchFamily="34" charset="0"/>
-                <a:ea typeface="Courier New" pitchFamily="34" charset="-122"/>
-                <a:cs typeface="Courier New" pitchFamily="34" charset="-120"/>
-              </a:rPr>
-              <a:t>          before check-in")</a:t>
-            </a:r>
-            <a:endParaRPr lang="en-US" sz="1050" dirty="0"/>
-          </a:p>
-          <a:p>
-            <a:pPr indent="0" marL="0">
-              <a:lnSpc>
-                <a:spcPct val="104000"/>
-              </a:lnSpc>
-              <a:buNone/>
-            </a:pPr>
-            <a:r>
-              <a:rPr lang="en-US" sz="1050" dirty="0">
-                <a:solidFill>
-                  <a:srgbClr val="141414"/>
-                </a:solidFill>
-                <a:latin typeface="Courier New" pitchFamily="34" charset="0"/>
-                <a:ea typeface="Courier New" pitchFamily="34" charset="-122"/>
-                <a:cs typeface="Courier New" pitchFamily="34" charset="-120"/>
-              </a:rPr>
-              <a:t>end</a:t>
-            </a:r>
-            <a:endParaRPr lang="en-US" sz="1050" dirty="0"/>
-          </a:p>
-          <a:p>
-            <a:pPr indent="0" marL="0">
-              <a:lnSpc>
-                <a:spcPct val="104000"/>
-              </a:lnSpc>
-              <a:buNone/>
-            </a:pPr>
-            <a:endParaRPr lang="en-US" sz="1050" dirty="0"/>
-          </a:p>
-          <a:p>
-            <a:pPr indent="0" marL="0">
-              <a:lnSpc>
-                <a:spcPct val="104000"/>
-              </a:lnSpc>
-              <a:buNone/>
-            </a:pPr>
-            <a:r>
-              <a:rPr lang="en-US" sz="1050" dirty="0">
-                <a:solidFill>
-                  <a:srgbClr val="141414"/>
-                </a:solidFill>
-                <a:latin typeface="Courier New" pitchFamily="34" charset="0"/>
-                <a:ea typeface="Courier New" pitchFamily="34" charset="-122"/>
-                <a:cs typeface="Courier New" pitchFamily="34" charset="-120"/>
-              </a:rPr>
-              <a:t># riding the transition:</a:t>
-            </a:r>
-            <a:endParaRPr lang="en-US" sz="1050" dirty="0"/>
-          </a:p>
-          <a:p>
-            <a:pPr indent="0" marL="0">
-              <a:lnSpc>
-                <a:spcPct val="104000"/>
-              </a:lnSpc>
-              <a:buNone/>
-            </a:pPr>
-            <a:r>
-              <a:rPr lang="en-US" sz="1050" dirty="0">
-                <a:solidFill>
-                  <a:srgbClr val="141414"/>
-                </a:solidFill>
-                <a:latin typeface="Courier New" pitchFamily="34" charset="0"/>
-                <a:ea typeface="Courier New" pitchFamily="34" charset="-122"/>
-                <a:cs typeface="Courier New" pitchFamily="34" charset="-120"/>
-              </a:rPr>
-              <a:t>change {ComplianceGuard,</a:t>
-            </a:r>
-            <a:endParaRPr lang="en-US" sz="1050" dirty="0"/>
-          </a:p>
-          <a:p>
-            <a:pPr indent="0" marL="0">
-              <a:lnSpc>
-                <a:spcPct val="104000"/>
-              </a:lnSpc>
-              <a:buNone/>
-            </a:pPr>
-            <a:r>
-              <a:rPr lang="en-US" sz="1050" dirty="0">
-                <a:solidFill>
-                  <a:srgbClr val="141414"/>
-                </a:solidFill>
-                <a:latin typeface="Courier New" pitchFamily="34" charset="0"/>
-                <a:ea typeface="Courier New" pitchFamily="34" charset="-122"/>
-                <a:cs typeface="Courier New" pitchFamily="34" charset="-120"/>
-              </a:rPr>
-              <a:t>        transition_to: :checked_in}</a:t>
+              <a:t>#   label: :full_name]</a:t>
             </a:r>
             <a:endParaRPr lang="en-US" sz="1050" dirty="0"/>
           </a:p>
@@ -7219,7 +8062,7 @@
       </p:sp>
       <p:pic>
         <p:nvPicPr>
-          <p:cNvPr id="8" name="Image 0" descr="/tmp/opencode/deck-shots/rules.png">    </p:cNvPr>
+          <p:cNvPr id="8" name="Image 0" descr="/tmp/opencode/deck-shots/board.png">    </p:cNvPr>
           <p:cNvPicPr>
             <a:picLocks noChangeAspect="1"/>
           </p:cNvPicPr>
@@ -7250,7 +8093,7 @@
         <p:spPr>
           <a:xfrm>
             <a:off x="6611112" y="4526280"/>
-            <a:ext cx="1117397" cy="310896"/>
+            <a:ext cx="967435" cy="310896"/>
           </a:xfrm>
           <a:prstGeom prst="roundRect">
             <a:avLst>
@@ -7284,7 +8127,7 @@
         <p:spPr>
           <a:xfrm>
             <a:off x="6611112" y="4526280"/>
-            <a:ext cx="1117397" cy="310896"/>
+            <a:ext cx="967435" cy="310896"/>
           </a:xfrm>
           <a:prstGeom prst="rect">
             <a:avLst/>
@@ -7308,7 +8151,7 @@
                 <a:ea typeface="Arial" pitchFamily="34" charset="-122"/>
                 <a:cs typeface="Arial" pitchFamily="34" charset="-120"/>
               </a:rPr>
-              <a:t>rule editor</a:t>
+              <a:t>the board</a:t>
             </a:r>
             <a:endParaRPr lang="en-US" sz="1100" dirty="0"/>
           </a:p>
@@ -7347,7 +8190,7 @@
                 <a:ea typeface="Calibri" pitchFamily="34" charset="-122"/>
                 <a:cs typeface="Calibri" pitchFamily="34" charset="-120"/>
               </a:rPr>
-              <a:t>The module compiles to a content-hashed bundle; the guard evaluates the activated bundle — rules in force are rows, drafted and approved through the lifecycle. Blocked actions quote the gap text verbatim.</a:t>
+              <a:t>Without a clinician picked at /acting-as, every write is refused — the board leads with the banner. The same declaration answers “why forbidden?” per policy, for agents and auditors alike.</a:t>
             </a:r>
             <a:endParaRPr lang="en-US" sz="1250" dirty="0"/>
           </a:p>
@@ -7418,7 +8261,7 @@
                 <a:ea typeface="Arial" pitchFamily="34" charset="-122"/>
                 <a:cs typeface="Arial" pitchFamily="34" charset="-120"/>
               </a:rPr>
-              <a:t>05 · PROCESS → TOKEN</a:t>
+              <a:t>04 · RULES → GUARD</a:t>
             </a:r>
             <a:endParaRPr lang="en-US" sz="1200" dirty="0"/>
           </a:p>
@@ -7457,7 +8300,7 @@
                 <a:ea typeface="Arial" pitchFamily="34" charset="-122"/>
                 <a:cs typeface="Arial" pitchFamily="34" charset="-120"/>
               </a:rPr>
-              <a:t>A document, executed as rows</a:t>
+              <a:t>The rulebook is data, not code</a:t>
             </a:r>
             <a:endParaRPr lang="en-US" sz="3000" dirty="0"/>
           </a:p>
@@ -7530,7 +8373,7 @@
                 <a:ea typeface="Courier New" pitchFamily="34" charset="-122"/>
                 <a:cs typeface="Courier New" pitchFamily="34" charset="-120"/>
               </a:rPr>
-              <a:t>priv/processes/appointment_visit.bpmn</a:t>
+              <a:t>lib/clinic_demo/compliance/appointment_rules.ex</a:t>
             </a:r>
             <a:endParaRPr lang="en-US" sz="1000" dirty="0"/>
           </a:p>
@@ -7572,8 +8415,17 @@
                 <a:ea typeface="Courier New" pitchFamily="34" charset="-122"/>
                 <a:cs typeface="Courier New" pitchFamily="34" charset="-120"/>
               </a:rPr>
-              <a:t>Start_booked</a:t>
-            </a:r>
+              <a:t>use AshRules</a:t>
+            </a:r>
+            <a:endParaRPr lang="en-US" sz="1050" dirty="0"/>
+          </a:p>
+          <a:p>
+            <a:pPr indent="0" marL="0">
+              <a:lnSpc>
+                <a:spcPct val="104000"/>
+              </a:lnSpc>
+              <a:buNone/>
+            </a:pPr>
             <a:endParaRPr lang="en-US" sz="1050" dirty="0"/>
           </a:p>
           <a:p>
@@ -7592,7 +8444,7 @@
                 <a:ea typeface="Courier New" pitchFamily="34" charset="-122"/>
                 <a:cs typeface="Courier New" pitchFamily="34" charset="-120"/>
               </a:rPr>
-              <a:t>  → Triage        (business rule → DMN)</a:t>
+              <a:t>rule "check-in requires a recorded weight",</a:t>
             </a:r>
             <a:endParaRPr lang="en-US" sz="1050" dirty="0"/>
           </a:p>
@@ -7612,7 +8464,7 @@
                 <a:ea typeface="Courier New" pitchFamily="34" charset="-122"/>
                 <a:cs typeface="Courier New" pitchFamily="34" charset="-120"/>
               </a:rPr>
-              <a:t>  → RecordUrgency (service → record_triage)</a:t>
+              <a:t>  id: "appt.checkin_requires_weight",</a:t>
             </a:r>
             <a:endParaRPr lang="en-US" sz="1050" dirty="0"/>
           </a:p>
@@ -7632,7 +8484,7 @@
                 <a:ea typeface="Courier New" pitchFamily="34" charset="-122"/>
                 <a:cs typeface="Courier New" pitchFamily="34" charset="-120"/>
               </a:rPr>
-              <a:t>  → CheckIn       (user task, nurses)</a:t>
+              <a:t>  severity: :high do</a:t>
             </a:r>
             <a:endParaRPr lang="en-US" sz="1050" dirty="0"/>
           </a:p>
@@ -7652,7 +8504,7 @@
                 <a:ea typeface="Courier New" pitchFamily="34" charset="-122"/>
                 <a:cs typeface="Courier New" pitchFamily="34" charset="-120"/>
               </a:rPr>
-              <a:t>  → Consult       (user task)</a:t>
+              <a:t>  when_requires(</a:t>
             </a:r>
             <a:endParaRPr lang="en-US" sz="1050" dirty="0"/>
           </a:p>
@@ -7672,17 +8524,8 @@
                 <a:ea typeface="Courier New" pitchFamily="34" charset="-122"/>
                 <a:cs typeface="Courier New" pitchFamily="34" charset="-120"/>
               </a:rPr>
-              <a:t>  → Discharge     (service)</a:t>
-            </a:r>
-            <a:endParaRPr lang="en-US" sz="1050" dirty="0"/>
-          </a:p>
-          <a:p>
-            <a:pPr indent="0" marL="0">
-              <a:lnSpc>
-                <a:spcPct val="104000"/>
-              </a:lnSpc>
-              <a:buNone/>
-            </a:pPr>
+              <a:t>    has(:appointment, :transition_to,</a:t>
+            </a:r>
             <a:endParaRPr lang="en-US" sz="1050" dirty="0"/>
           </a:p>
           <a:p>
@@ -7701,7 +8544,7 @@
                 <a:ea typeface="Courier New" pitchFamily="34" charset="-122"/>
                 <a:cs typeface="Courier New" pitchFamily="34" charset="-120"/>
               </a:rPr>
-              <a:t># service tasks name the Ash action</a:t>
+              <a:t>        :checked_in))</a:t>
             </a:r>
             <a:endParaRPr lang="en-US" sz="1050" dirty="0"/>
           </a:p>
@@ -7721,17 +8564,8 @@
                 <a:ea typeface="Courier New" pitchFamily="34" charset="-122"/>
                 <a:cs typeface="Courier New" pitchFamily="34" charset="-120"/>
               </a:rPr>
-              <a:t># they call; the engine invokes it.</a:t>
-            </a:r>
-            <a:endParaRPr lang="en-US" sz="1050" dirty="0"/>
-          </a:p>
-          <a:p>
-            <a:pPr indent="0" marL="0">
-              <a:lnSpc>
-                <a:spcPct val="104000"/>
-              </a:lnSpc>
-              <a:buNone/>
-            </a:pPr>
+              <a:t>  fails_when(</a:t>
+            </a:r>
             <a:endParaRPr lang="en-US" sz="1050" dirty="0"/>
           </a:p>
           <a:p>
@@ -7750,7 +8584,7 @@
                 <a:ea typeface="Courier New" pitchFamily="34" charset="-122"/>
                 <a:cs typeface="Courier New" pitchFamily="34" charset="-120"/>
               </a:rPr>
-              <a:t>create :book do</a:t>
+              <a:t>    neg(:appointment,</a:t>
             </a:r>
             <a:endParaRPr lang="en-US" sz="1050" dirty="0"/>
           </a:p>
@@ -7770,7 +8604,7 @@
                 <a:ea typeface="Courier New" pitchFamily="34" charset="-122"/>
                 <a:cs typeface="Courier New" pitchFamily="34" charset="-120"/>
               </a:rPr>
-              <a:t>  change StartVisitProcess  # in-txn</a:t>
+              <a:t>        :patient_weight_recorded, true))</a:t>
             </a:r>
             <a:endParaRPr lang="en-US" sz="1050" dirty="0"/>
           </a:p>
@@ -7790,7 +8624,136 @@
                 <a:ea typeface="Courier New" pitchFamily="34" charset="-122"/>
                 <a:cs typeface="Courier New" pitchFamily="34" charset="-120"/>
               </a:rPr>
+              <a:t>  outcome(:noncompliant,</a:t>
+            </a:r>
+            <a:endParaRPr lang="en-US" sz="1050" dirty="0"/>
+          </a:p>
+          <a:p>
+            <a:pPr indent="0" marL="0">
+              <a:lnSpc>
+                <a:spcPct val="104000"/>
+              </a:lnSpc>
+              <a:buNone/>
+            </a:pPr>
+            <a:r>
+              <a:rPr lang="en-US" sz="1050" dirty="0">
+                <a:solidFill>
+                  <a:srgbClr val="141414"/>
+                </a:solidFill>
+                <a:latin typeface="Courier New" pitchFamily="34" charset="0"/>
+                <a:ea typeface="Courier New" pitchFamily="34" charset="-122"/>
+                <a:cs typeface="Courier New" pitchFamily="34" charset="-120"/>
+              </a:rPr>
+              <a:t>    gap: "record the patient's weight</a:t>
+            </a:r>
+            <a:endParaRPr lang="en-US" sz="1050" dirty="0"/>
+          </a:p>
+          <a:p>
+            <a:pPr indent="0" marL="0">
+              <a:lnSpc>
+                <a:spcPct val="104000"/>
+              </a:lnSpc>
+              <a:buNone/>
+            </a:pPr>
+            <a:r>
+              <a:rPr lang="en-US" sz="1050" dirty="0">
+                <a:solidFill>
+                  <a:srgbClr val="141414"/>
+                </a:solidFill>
+                <a:latin typeface="Courier New" pitchFamily="34" charset="0"/>
+                <a:ea typeface="Courier New" pitchFamily="34" charset="-122"/>
+                <a:cs typeface="Courier New" pitchFamily="34" charset="-120"/>
+              </a:rPr>
+              <a:t>          before check-in")</a:t>
+            </a:r>
+            <a:endParaRPr lang="en-US" sz="1050" dirty="0"/>
+          </a:p>
+          <a:p>
+            <a:pPr indent="0" marL="0">
+              <a:lnSpc>
+                <a:spcPct val="104000"/>
+              </a:lnSpc>
+              <a:buNone/>
+            </a:pPr>
+            <a:r>
+              <a:rPr lang="en-US" sz="1050" dirty="0">
+                <a:solidFill>
+                  <a:srgbClr val="141414"/>
+                </a:solidFill>
+                <a:latin typeface="Courier New" pitchFamily="34" charset="0"/>
+                <a:ea typeface="Courier New" pitchFamily="34" charset="-122"/>
+                <a:cs typeface="Courier New" pitchFamily="34" charset="-120"/>
+              </a:rPr>
               <a:t>end</a:t>
+            </a:r>
+            <a:endParaRPr lang="en-US" sz="1050" dirty="0"/>
+          </a:p>
+          <a:p>
+            <a:pPr indent="0" marL="0">
+              <a:lnSpc>
+                <a:spcPct val="104000"/>
+              </a:lnSpc>
+              <a:buNone/>
+            </a:pPr>
+            <a:endParaRPr lang="en-US" sz="1050" dirty="0"/>
+          </a:p>
+          <a:p>
+            <a:pPr indent="0" marL="0">
+              <a:lnSpc>
+                <a:spcPct val="104000"/>
+              </a:lnSpc>
+              <a:buNone/>
+            </a:pPr>
+            <a:r>
+              <a:rPr lang="en-US" sz="1050" dirty="0">
+                <a:solidFill>
+                  <a:srgbClr val="141414"/>
+                </a:solidFill>
+                <a:latin typeface="Courier New" pitchFamily="34" charset="0"/>
+                <a:ea typeface="Courier New" pitchFamily="34" charset="-122"/>
+                <a:cs typeface="Courier New" pitchFamily="34" charset="-120"/>
+              </a:rPr>
+              <a:t># riding the transition:</a:t>
+            </a:r>
+            <a:endParaRPr lang="en-US" sz="1050" dirty="0"/>
+          </a:p>
+          <a:p>
+            <a:pPr indent="0" marL="0">
+              <a:lnSpc>
+                <a:spcPct val="104000"/>
+              </a:lnSpc>
+              <a:buNone/>
+            </a:pPr>
+            <a:r>
+              <a:rPr lang="en-US" sz="1050" dirty="0">
+                <a:solidFill>
+                  <a:srgbClr val="141414"/>
+                </a:solidFill>
+                <a:latin typeface="Courier New" pitchFamily="34" charset="0"/>
+                <a:ea typeface="Courier New" pitchFamily="34" charset="-122"/>
+                <a:cs typeface="Courier New" pitchFamily="34" charset="-120"/>
+              </a:rPr>
+              <a:t>change {ComplianceGuard,</a:t>
+            </a:r>
+            <a:endParaRPr lang="en-US" sz="1050" dirty="0"/>
+          </a:p>
+          <a:p>
+            <a:pPr indent="0" marL="0">
+              <a:lnSpc>
+                <a:spcPct val="104000"/>
+              </a:lnSpc>
+              <a:buNone/>
+            </a:pPr>
+            <a:r>
+              <a:rPr lang="en-US" sz="1050" dirty="0">
+                <a:solidFill>
+                  <a:srgbClr val="141414"/>
+                </a:solidFill>
+                <a:latin typeface="Courier New" pitchFamily="34" charset="0"/>
+                <a:ea typeface="Courier New" pitchFamily="34" charset="-122"/>
+                <a:cs typeface="Courier New" pitchFamily="34" charset="-120"/>
+              </a:rPr>
+              <a:t>        transition_to: :checked_in}</a:t>
             </a:r>
             <a:endParaRPr lang="en-US" sz="1050" dirty="0"/>
           </a:p>
@@ -7832,7 +8795,7 @@
       </p:sp>
       <p:pic>
         <p:nvPicPr>
-          <p:cNvPr id="8" name="Image 0" descr="/tmp/opencode/deck-shots/instance.png">    </p:cNvPr>
+          <p:cNvPr id="8" name="Image 0" descr="/tmp/opencode/deck-shots/rules.png">    </p:cNvPr>
           <p:cNvPicPr>
             <a:picLocks noChangeAspect="1"/>
           </p:cNvPicPr>
@@ -7863,7 +8826,7 @@
         <p:spPr>
           <a:xfrm>
             <a:off x="6611112" y="4526280"/>
-            <a:ext cx="1417320" cy="310896"/>
+            <a:ext cx="1117397" cy="310896"/>
           </a:xfrm>
           <a:prstGeom prst="roundRect">
             <a:avLst>
@@ -7897,7 +8860,7 @@
         <p:spPr>
           <a:xfrm>
             <a:off x="6611112" y="4526280"/>
-            <a:ext cx="1417320" cy="310896"/>
+            <a:ext cx="1117397" cy="310896"/>
           </a:xfrm>
           <a:prstGeom prst="rect">
             <a:avLst/>
@@ -7921,7 +8884,7 @@
                 <a:ea typeface="Arial" pitchFamily="34" charset="-122"/>
                 <a:cs typeface="Arial" pitchFamily="34" charset="-120"/>
               </a:rPr>
-              <a:t>instance viewer</a:t>
+              <a:t>rule editor</a:t>
             </a:r>
             <a:endParaRPr lang="en-US" sz="1100" dirty="0"/>
           </a:p>
@@ -7960,7 +8923,7 @@
                 <a:ea typeface="Calibri" pitchFamily="34" charset="-122"/>
                 <a:cs typeface="Calibri" pitchFamily="34" charset="-120"/>
               </a:rPr>
-              <a:t>Booking starts the process inside the transaction. Open any visit from the hub: the diagram draws with the current node highlighted — waiting dashed, executing pulsing — and every guarded decision lands in the evidence trail.</a:t>
+              <a:t>The module compiles to a content-hashed bundle; the guard evaluates the activated bundle — rules in force are rows, drafted and approved through the lifecycle. Blocked actions quote the gap text verbatim.</a:t>
             </a:r>
             <a:endParaRPr lang="en-US" sz="1250" dirty="0"/>
           </a:p>
@@ -8031,7 +8994,7 @@
                 <a:ea typeface="Arial" pitchFamily="34" charset="-122"/>
                 <a:cs typeface="Arial" pitchFamily="34" charset="-120"/>
               </a:rPr>
-              <a:t>THE AGENT STORY</a:t>
+              <a:t>05 · PROCESS → TOKEN</a:t>
             </a:r>
             <a:endParaRPr lang="en-US" sz="1200" dirty="0"/>
           </a:p>
@@ -8070,7 +9033,7 @@
                 <a:ea typeface="Arial" pitchFamily="34" charset="-122"/>
                 <a:cs typeface="Arial" pitchFamily="34" charset="-120"/>
               </a:rPr>
-              <a:t>The stack is agent-native, end to end</a:t>
+              <a:t>A document, executed as rows</a:t>
             </a:r>
             <a:endParaRPr lang="en-US" sz="3000" dirty="0"/>
           </a:p>
@@ -8084,12 +9047,12 @@
         </p:nvSpPr>
         <p:spPr>
           <a:xfrm>
-            <a:off x="502920" y="1691640"/>
-            <a:ext cx="11155680" cy="914400"/>
+            <a:off x="502920" y="1600200"/>
+            <a:ext cx="5577840" cy="4160520"/>
           </a:xfrm>
           <a:prstGeom prst="roundRect">
             <a:avLst>
-              <a:gd name="adj" fmla="val 6000"/>
+              <a:gd name="adj" fmla="val 1319"/>
             </a:avLst>
           </a:prstGeom>
           <a:solidFill>
@@ -8112,130 +9075,317 @@
       </p:sp>
       <p:sp>
         <p:nvSpPr>
-          <p:cNvPr id="5" name="Shape 3"/>
+          <p:cNvPr id="5" name="Text 3"/>
+          <p:cNvSpPr txBox="1"/>
+          <p:nvPr/>
+        </p:nvSpPr>
+        <p:spPr>
+          <a:xfrm>
+            <a:off x="704088" y="1728216"/>
+            <a:ext cx="5175504" cy="274320"/>
+          </a:xfrm>
+          <a:prstGeom prst="rect">
+            <a:avLst/>
+          </a:prstGeom>
+          <a:noFill/>
+          <a:ln/>
+        </p:spPr>
+        <p:txBody>
+          <a:bodyPr wrap="square" lIns="0" tIns="0" rIns="0" bIns="0" rtlCol="0" anchor="ctr"/>
+          <a:lstStyle/>
+          <a:p>
+            <a:pPr indent="0" marL="0">
+              <a:buNone/>
+            </a:pPr>
+            <a:r>
+              <a:rPr lang="en-US" sz="1000" b="1" dirty="0">
+                <a:solidFill>
+                  <a:srgbClr val="5B6472"/>
+                </a:solidFill>
+                <a:latin typeface="Courier New" pitchFamily="34" charset="0"/>
+                <a:ea typeface="Courier New" pitchFamily="34" charset="-122"/>
+                <a:cs typeface="Courier New" pitchFamily="34" charset="-120"/>
+              </a:rPr>
+              <a:t>priv/processes/appointment_visit.bpmn</a:t>
+            </a:r>
+            <a:endParaRPr lang="en-US" sz="1000" dirty="0"/>
+          </a:p>
+        </p:txBody>
+      </p:sp>
+      <p:sp>
+        <p:nvSpPr>
+          <p:cNvPr id="6" name="Text 4"/>
+          <p:cNvSpPr txBox="1"/>
+          <p:nvPr/>
+        </p:nvSpPr>
+        <p:spPr>
+          <a:xfrm>
+            <a:off x="704088" y="2020824"/>
+            <a:ext cx="5212080" cy="3593592"/>
+          </a:xfrm>
+          <a:prstGeom prst="rect">
+            <a:avLst/>
+          </a:prstGeom>
+          <a:noFill/>
+          <a:ln/>
+        </p:spPr>
+        <p:txBody>
+          <a:bodyPr wrap="square" lIns="0" tIns="0" rIns="0" bIns="0" rtlCol="0" anchor="t"/>
+          <a:lstStyle/>
+          <a:p>
+            <a:pPr indent="0" marL="0">
+              <a:lnSpc>
+                <a:spcPct val="104000"/>
+              </a:lnSpc>
+              <a:buNone/>
+            </a:pPr>
+            <a:r>
+              <a:rPr lang="en-US" sz="1050" dirty="0">
+                <a:solidFill>
+                  <a:srgbClr val="141414"/>
+                </a:solidFill>
+                <a:latin typeface="Courier New" pitchFamily="34" charset="0"/>
+                <a:ea typeface="Courier New" pitchFamily="34" charset="-122"/>
+                <a:cs typeface="Courier New" pitchFamily="34" charset="-120"/>
+              </a:rPr>
+              <a:t>Start_booked</a:t>
+            </a:r>
+            <a:endParaRPr lang="en-US" sz="1050" dirty="0"/>
+          </a:p>
+          <a:p>
+            <a:pPr indent="0" marL="0">
+              <a:lnSpc>
+                <a:spcPct val="104000"/>
+              </a:lnSpc>
+              <a:buNone/>
+            </a:pPr>
+            <a:r>
+              <a:rPr lang="en-US" sz="1050" dirty="0">
+                <a:solidFill>
+                  <a:srgbClr val="141414"/>
+                </a:solidFill>
+                <a:latin typeface="Courier New" pitchFamily="34" charset="0"/>
+                <a:ea typeface="Courier New" pitchFamily="34" charset="-122"/>
+                <a:cs typeface="Courier New" pitchFamily="34" charset="-120"/>
+              </a:rPr>
+              <a:t>  → Triage        (business rule → DMN)</a:t>
+            </a:r>
+            <a:endParaRPr lang="en-US" sz="1050" dirty="0"/>
+          </a:p>
+          <a:p>
+            <a:pPr indent="0" marL="0">
+              <a:lnSpc>
+                <a:spcPct val="104000"/>
+              </a:lnSpc>
+              <a:buNone/>
+            </a:pPr>
+            <a:r>
+              <a:rPr lang="en-US" sz="1050" dirty="0">
+                <a:solidFill>
+                  <a:srgbClr val="141414"/>
+                </a:solidFill>
+                <a:latin typeface="Courier New" pitchFamily="34" charset="0"/>
+                <a:ea typeface="Courier New" pitchFamily="34" charset="-122"/>
+                <a:cs typeface="Courier New" pitchFamily="34" charset="-120"/>
+              </a:rPr>
+              <a:t>  → RecordUrgency (service → record_triage)</a:t>
+            </a:r>
+            <a:endParaRPr lang="en-US" sz="1050" dirty="0"/>
+          </a:p>
+          <a:p>
+            <a:pPr indent="0" marL="0">
+              <a:lnSpc>
+                <a:spcPct val="104000"/>
+              </a:lnSpc>
+              <a:buNone/>
+            </a:pPr>
+            <a:r>
+              <a:rPr lang="en-US" sz="1050" dirty="0">
+                <a:solidFill>
+                  <a:srgbClr val="141414"/>
+                </a:solidFill>
+                <a:latin typeface="Courier New" pitchFamily="34" charset="0"/>
+                <a:ea typeface="Courier New" pitchFamily="34" charset="-122"/>
+                <a:cs typeface="Courier New" pitchFamily="34" charset="-120"/>
+              </a:rPr>
+              <a:t>  → CheckIn       (user task, nurses)</a:t>
+            </a:r>
+            <a:endParaRPr lang="en-US" sz="1050" dirty="0"/>
+          </a:p>
+          <a:p>
+            <a:pPr indent="0" marL="0">
+              <a:lnSpc>
+                <a:spcPct val="104000"/>
+              </a:lnSpc>
+              <a:buNone/>
+            </a:pPr>
+            <a:r>
+              <a:rPr lang="en-US" sz="1050" dirty="0">
+                <a:solidFill>
+                  <a:srgbClr val="141414"/>
+                </a:solidFill>
+                <a:latin typeface="Courier New" pitchFamily="34" charset="0"/>
+                <a:ea typeface="Courier New" pitchFamily="34" charset="-122"/>
+                <a:cs typeface="Courier New" pitchFamily="34" charset="-120"/>
+              </a:rPr>
+              <a:t>  → Consult       (user task)</a:t>
+            </a:r>
+            <a:endParaRPr lang="en-US" sz="1050" dirty="0"/>
+          </a:p>
+          <a:p>
+            <a:pPr indent="0" marL="0">
+              <a:lnSpc>
+                <a:spcPct val="104000"/>
+              </a:lnSpc>
+              <a:buNone/>
+            </a:pPr>
+            <a:r>
+              <a:rPr lang="en-US" sz="1050" dirty="0">
+                <a:solidFill>
+                  <a:srgbClr val="141414"/>
+                </a:solidFill>
+                <a:latin typeface="Courier New" pitchFamily="34" charset="0"/>
+                <a:ea typeface="Courier New" pitchFamily="34" charset="-122"/>
+                <a:cs typeface="Courier New" pitchFamily="34" charset="-120"/>
+              </a:rPr>
+              <a:t>  → Discharge     (service)</a:t>
+            </a:r>
+            <a:endParaRPr lang="en-US" sz="1050" dirty="0"/>
+          </a:p>
+          <a:p>
+            <a:pPr indent="0" marL="0">
+              <a:lnSpc>
+                <a:spcPct val="104000"/>
+              </a:lnSpc>
+              <a:buNone/>
+            </a:pPr>
+            <a:endParaRPr lang="en-US" sz="1050" dirty="0"/>
+          </a:p>
+          <a:p>
+            <a:pPr indent="0" marL="0">
+              <a:lnSpc>
+                <a:spcPct val="104000"/>
+              </a:lnSpc>
+              <a:buNone/>
+            </a:pPr>
+            <a:r>
+              <a:rPr lang="en-US" sz="1050" dirty="0">
+                <a:solidFill>
+                  <a:srgbClr val="141414"/>
+                </a:solidFill>
+                <a:latin typeface="Courier New" pitchFamily="34" charset="0"/>
+                <a:ea typeface="Courier New" pitchFamily="34" charset="-122"/>
+                <a:cs typeface="Courier New" pitchFamily="34" charset="-120"/>
+              </a:rPr>
+              <a:t># service tasks name the Ash action</a:t>
+            </a:r>
+            <a:endParaRPr lang="en-US" sz="1050" dirty="0"/>
+          </a:p>
+          <a:p>
+            <a:pPr indent="0" marL="0">
+              <a:lnSpc>
+                <a:spcPct val="104000"/>
+              </a:lnSpc>
+              <a:buNone/>
+            </a:pPr>
+            <a:r>
+              <a:rPr lang="en-US" sz="1050" dirty="0">
+                <a:solidFill>
+                  <a:srgbClr val="141414"/>
+                </a:solidFill>
+                <a:latin typeface="Courier New" pitchFamily="34" charset="0"/>
+                <a:ea typeface="Courier New" pitchFamily="34" charset="-122"/>
+                <a:cs typeface="Courier New" pitchFamily="34" charset="-120"/>
+              </a:rPr>
+              <a:t># they call; the engine invokes it.</a:t>
+            </a:r>
+            <a:endParaRPr lang="en-US" sz="1050" dirty="0"/>
+          </a:p>
+          <a:p>
+            <a:pPr indent="0" marL="0">
+              <a:lnSpc>
+                <a:spcPct val="104000"/>
+              </a:lnSpc>
+              <a:buNone/>
+            </a:pPr>
+            <a:endParaRPr lang="en-US" sz="1050" dirty="0"/>
+          </a:p>
+          <a:p>
+            <a:pPr indent="0" marL="0">
+              <a:lnSpc>
+                <a:spcPct val="104000"/>
+              </a:lnSpc>
+              <a:buNone/>
+            </a:pPr>
+            <a:r>
+              <a:rPr lang="en-US" sz="1050" dirty="0">
+                <a:solidFill>
+                  <a:srgbClr val="141414"/>
+                </a:solidFill>
+                <a:latin typeface="Courier New" pitchFamily="34" charset="0"/>
+                <a:ea typeface="Courier New" pitchFamily="34" charset="-122"/>
+                <a:cs typeface="Courier New" pitchFamily="34" charset="-120"/>
+              </a:rPr>
+              <a:t>create :book do</a:t>
+            </a:r>
+            <a:endParaRPr lang="en-US" sz="1050" dirty="0"/>
+          </a:p>
+          <a:p>
+            <a:pPr indent="0" marL="0">
+              <a:lnSpc>
+                <a:spcPct val="104000"/>
+              </a:lnSpc>
+              <a:buNone/>
+            </a:pPr>
+            <a:r>
+              <a:rPr lang="en-US" sz="1050" dirty="0">
+                <a:solidFill>
+                  <a:srgbClr val="141414"/>
+                </a:solidFill>
+                <a:latin typeface="Courier New" pitchFamily="34" charset="0"/>
+                <a:ea typeface="Courier New" pitchFamily="34" charset="-122"/>
+                <a:cs typeface="Courier New" pitchFamily="34" charset="-120"/>
+              </a:rPr>
+              <a:t>  change StartVisitProcess  # in-txn</a:t>
+            </a:r>
+            <a:endParaRPr lang="en-US" sz="1050" dirty="0"/>
+          </a:p>
+          <a:p>
+            <a:pPr indent="0" marL="0">
+              <a:lnSpc>
+                <a:spcPct val="104000"/>
+              </a:lnSpc>
+              <a:buNone/>
+            </a:pPr>
+            <a:r>
+              <a:rPr lang="en-US" sz="1050" dirty="0">
+                <a:solidFill>
+                  <a:srgbClr val="141414"/>
+                </a:solidFill>
+                <a:latin typeface="Courier New" pitchFamily="34" charset="0"/>
+                <a:ea typeface="Courier New" pitchFamily="34" charset="-122"/>
+                <a:cs typeface="Courier New" pitchFamily="34" charset="-120"/>
+              </a:rPr>
+              <a:t>end</a:t>
+            </a:r>
+            <a:endParaRPr lang="en-US" sz="1050" dirty="0"/>
+          </a:p>
+        </p:txBody>
+      </p:sp>
+      <p:sp>
+        <p:nvSpPr>
+          <p:cNvPr id="7" name="Shape 5"/>
           <p:cNvSpPr/>
           <p:nvPr/>
         </p:nvSpPr>
         <p:spPr>
           <a:xfrm>
-            <a:off x="777240" y="1975104"/>
-            <a:ext cx="1417320" cy="310896"/>
+            <a:off x="6336792" y="1673352"/>
+            <a:ext cx="5340096" cy="3419856"/>
           </a:xfrm>
           <a:prstGeom prst="roundRect">
             <a:avLst>
-              <a:gd name="adj" fmla="val 50000"/>
-            </a:avLst>
-          </a:prstGeom>
-          <a:solidFill>
-            <a:srgbClr val="DCE9FC"/>
-          </a:solidFill>
-          <a:ln w="22225">
-            <a:solidFill>
-              <a:srgbClr val="141414"/>
-            </a:solidFill>
-            <a:prstDash val="solid"/>
-          </a:ln>
-          <a:effectLst>
-            <a:outerShdw sx="100000" sy="100000" kx="0" ky="0" algn="bl" rotWithShape="0" blurRad="101600" dist="38100" dir="2700000">
-              <a:srgbClr val="141414">
-                <a:alpha val="100000"/>
-              </a:srgbClr>
-            </a:outerShdw>
-          </a:effectLst>
-        </p:spPr>
-      </p:sp>
-      <p:sp>
-        <p:nvSpPr>
-          <p:cNvPr id="6" name="Text 4"/>
-          <p:cNvSpPr txBox="1"/>
-          <p:nvPr/>
-        </p:nvSpPr>
-        <p:spPr>
-          <a:xfrm>
-            <a:off x="777240" y="1975104"/>
-            <a:ext cx="1417320" cy="310896"/>
-          </a:xfrm>
-          <a:prstGeom prst="rect">
-            <a:avLst/>
-          </a:prstGeom>
-          <a:noFill/>
-          <a:ln/>
-        </p:spPr>
-        <p:txBody>
-          <a:bodyPr wrap="square" lIns="0" tIns="0" rIns="0" bIns="0" rtlCol="0" anchor="ctr"/>
-          <a:lstStyle/>
-          <a:p>
-            <a:pPr algn="ctr" indent="0" marL="0">
-              <a:buNone/>
-            </a:pPr>
-            <a:r>
-              <a:rPr lang="en-US" sz="1100" b="1" dirty="0">
-                <a:solidFill>
-                  <a:srgbClr val="141414"/>
-                </a:solidFill>
-                <a:latin typeface="Arial" pitchFamily="34" charset="0"/>
-                <a:ea typeface="Arial" pitchFamily="34" charset="-122"/>
-                <a:cs typeface="Arial" pitchFamily="34" charset="-120"/>
-              </a:rPr>
-              <a:t>ash_agent_tools</a:t>
-            </a:r>
-            <a:endParaRPr lang="en-US" sz="1100" dirty="0"/>
-          </a:p>
-        </p:txBody>
-      </p:sp>
-      <p:sp>
-        <p:nvSpPr>
-          <p:cNvPr id="7" name="Text 5"/>
-          <p:cNvSpPr txBox="1"/>
-          <p:nvPr/>
-        </p:nvSpPr>
-        <p:spPr>
-          <a:xfrm>
-            <a:off x="3794760" y="1856232"/>
-            <a:ext cx="7680960" cy="621792"/>
-          </a:xfrm>
-          <a:prstGeom prst="rect">
-            <a:avLst/>
-          </a:prstGeom>
-          <a:noFill/>
-          <a:ln/>
-        </p:spPr>
-        <p:txBody>
-          <a:bodyPr wrap="square" lIns="0" tIns="0" rIns="0" bIns="0" rtlCol="0" anchor="ctr"/>
-          <a:lstStyle/>
-          <a:p>
-            <a:pPr indent="0" marL="0">
-              <a:buNone/>
-            </a:pPr>
-            <a:r>
-              <a:rPr lang="en-US" sz="1350" dirty="0">
-                <a:solidFill>
-                  <a:srgbClr val="141414"/>
-                </a:solidFill>
-                <a:latin typeface="Calibri" pitchFamily="34" charset="0"/>
-                <a:ea typeface="Calibri" pitchFamily="34" charset="-122"/>
-                <a:cs typeface="Calibri" pitchFamily="34" charset="-120"/>
-              </a:rPr>
-              <a:t>describe / can / evaluate / edit — the contract, readable by machines; semantic edits with compile gates</a:t>
-            </a:r>
-            <a:endParaRPr lang="en-US" sz="1350" dirty="0"/>
-          </a:p>
-        </p:txBody>
-      </p:sp>
-      <p:sp>
-        <p:nvSpPr>
-          <p:cNvPr id="8" name="Shape 6"/>
-          <p:cNvSpPr/>
-          <p:nvPr/>
-        </p:nvSpPr>
-        <p:spPr>
-          <a:xfrm>
-            <a:off x="502920" y="2770632"/>
-            <a:ext cx="11155680" cy="914400"/>
-          </a:xfrm>
-          <a:prstGeom prst="roundRect">
-            <a:avLst>
-              <a:gd name="adj" fmla="val 6000"/>
+              <a:gd name="adj" fmla="val 1604"/>
             </a:avLst>
           </a:prstGeom>
           <a:solidFill>
@@ -8256,308 +9406,40 @@
           </a:effectLst>
         </p:spPr>
       </p:sp>
-      <p:sp>
-        <p:nvSpPr>
-          <p:cNvPr id="9" name="Shape 7"/>
+      <p:pic>
+        <p:nvPicPr>
+          <p:cNvPr id="8" name="Image 0" descr="/tmp/opencode/deck-shots/instance.png">    </p:cNvPr>
+          <p:cNvPicPr>
+            <a:picLocks noChangeAspect="1"/>
+          </p:cNvPicPr>
+          <p:nvPr/>
+        </p:nvPicPr>
+        <p:blipFill>
+          <a:blip r:embed="rId1"/>
+          <a:stretch>
+            <a:fillRect/>
+          </a:stretch>
+        </p:blipFill>
+        <p:spPr>
+          <a:xfrm>
+            <a:off x="6446520" y="1783080"/>
+            <a:ext cx="5120640" cy="3200400"/>
+          </a:xfrm>
+          <a:prstGeom prst="rect">
+            <a:avLst/>
+          </a:prstGeom>
+        </p:spPr>
+      </p:pic>
+      <p:sp>
+        <p:nvSpPr>
+          <p:cNvPr id="9" name="Shape 6"/>
           <p:cNvSpPr/>
           <p:nvPr/>
         </p:nvSpPr>
         <p:spPr>
           <a:xfrm>
-            <a:off x="777240" y="3054096"/>
-            <a:ext cx="1192378" cy="310896"/>
-          </a:xfrm>
-          <a:prstGeom prst="roundRect">
-            <a:avLst>
-              <a:gd name="adj" fmla="val 50000"/>
-            </a:avLst>
-          </a:prstGeom>
-          <a:solidFill>
-            <a:srgbClr val="DCE9FC"/>
-          </a:solidFill>
-          <a:ln w="22225">
-            <a:solidFill>
-              <a:srgbClr val="141414"/>
-            </a:solidFill>
-            <a:prstDash val="solid"/>
-          </a:ln>
-          <a:effectLst>
-            <a:outerShdw sx="100000" sy="100000" kx="0" ky="0" algn="bl" rotWithShape="0" blurRad="101600" dist="38100" dir="2700000">
-              <a:srgbClr val="141414">
-                <a:alpha val="100000"/>
-              </a:srgbClr>
-            </a:outerShdw>
-          </a:effectLst>
-        </p:spPr>
-      </p:sp>
-      <p:sp>
-        <p:nvSpPr>
-          <p:cNvPr id="10" name="Text 8"/>
-          <p:cNvSpPr txBox="1"/>
-          <p:nvPr/>
-        </p:nvSpPr>
-        <p:spPr>
-          <a:xfrm>
-            <a:off x="777240" y="3054096"/>
-            <a:ext cx="1192378" cy="310896"/>
-          </a:xfrm>
-          <a:prstGeom prst="rect">
-            <a:avLst/>
-          </a:prstGeom>
-          <a:noFill/>
-          <a:ln/>
-        </p:spPr>
-        <p:txBody>
-          <a:bodyPr wrap="square" lIns="0" tIns="0" rIns="0" bIns="0" rtlCol="0" anchor="ctr"/>
-          <a:lstStyle/>
-          <a:p>
-            <a:pPr algn="ctr" indent="0" marL="0">
-              <a:buNone/>
-            </a:pPr>
-            <a:r>
-              <a:rPr lang="en-US" sz="1100" b="1" dirty="0">
-                <a:solidFill>
-                  <a:srgbClr val="141414"/>
-                </a:solidFill>
-                <a:latin typeface="Arial" pitchFamily="34" charset="0"/>
-                <a:ea typeface="Arial" pitchFamily="34" charset="-122"/>
-                <a:cs typeface="Arial" pitchFamily="34" charset="-120"/>
-              </a:rPr>
-              <a:t>Tidewave MCP</a:t>
-            </a:r>
-            <a:endParaRPr lang="en-US" sz="1100" dirty="0"/>
-          </a:p>
-        </p:txBody>
-      </p:sp>
-      <p:sp>
-        <p:nvSpPr>
-          <p:cNvPr id="11" name="Text 9"/>
-          <p:cNvSpPr txBox="1"/>
-          <p:nvPr/>
-        </p:nvSpPr>
-        <p:spPr>
-          <a:xfrm>
-            <a:off x="3794760" y="2935224"/>
-            <a:ext cx="7680960" cy="621792"/>
-          </a:xfrm>
-          <a:prstGeom prst="rect">
-            <a:avLst/>
-          </a:prstGeom>
-          <a:noFill/>
-          <a:ln/>
-        </p:spPr>
-        <p:txBody>
-          <a:bodyPr wrap="square" lIns="0" tIns="0" rIns="0" bIns="0" rtlCol="0" anchor="ctr"/>
-          <a:lstStyle/>
-          <a:p>
-            <a:pPr indent="0" marL="0">
-              <a:buNone/>
-            </a:pPr>
-            <a:r>
-              <a:rPr lang="en-US" sz="1350" dirty="0">
-                <a:solidFill>
-                  <a:srgbClr val="141414"/>
-                </a:solidFill>
-                <a:latin typeface="Calibri" pitchFamily="34" charset="0"/>
-                <a:ea typeface="Calibri" pitchFamily="34" charset="-122"/>
-                <a:cs typeface="Calibri" pitchFamily="34" charset="-120"/>
-              </a:rPr>
-              <a:t>project_eval in the running app — Ash reflection, logs, SQL; get_docs at exact lockfile versions</a:t>
-            </a:r>
-            <a:endParaRPr lang="en-US" sz="1350" dirty="0"/>
-          </a:p>
-        </p:txBody>
-      </p:sp>
-      <p:sp>
-        <p:nvSpPr>
-          <p:cNvPr id="12" name="Shape 10"/>
-          <p:cNvSpPr/>
-          <p:nvPr/>
-        </p:nvSpPr>
-        <p:spPr>
-          <a:xfrm>
-            <a:off x="502920" y="3849624"/>
-            <a:ext cx="11155680" cy="914400"/>
-          </a:xfrm>
-          <a:prstGeom prst="roundRect">
-            <a:avLst>
-              <a:gd name="adj" fmla="val 6000"/>
-            </a:avLst>
-          </a:prstGeom>
-          <a:solidFill>
-            <a:srgbClr val="FFFFFF"/>
-          </a:solidFill>
-          <a:ln w="25400">
-            <a:solidFill>
-              <a:srgbClr val="141414"/>
-            </a:solidFill>
-            <a:prstDash val="solid"/>
-          </a:ln>
-          <a:effectLst>
-            <a:outerShdw sx="100000" sy="100000" kx="0" ky="0" algn="bl" rotWithShape="0" blurRad="101600" dist="63500" dir="2700000">
-              <a:srgbClr val="141414">
-                <a:alpha val="100000"/>
-              </a:srgbClr>
-            </a:outerShdw>
-          </a:effectLst>
-        </p:spPr>
-      </p:sp>
-      <p:sp>
-        <p:nvSpPr>
-          <p:cNvPr id="13" name="Shape 11"/>
-          <p:cNvSpPr/>
-          <p:nvPr/>
-        </p:nvSpPr>
-        <p:spPr>
-          <a:xfrm>
-            <a:off x="777240" y="4133088"/>
-            <a:ext cx="1792224" cy="310896"/>
-          </a:xfrm>
-          <a:prstGeom prst="roundRect">
-            <a:avLst>
-              <a:gd name="adj" fmla="val 50000"/>
-            </a:avLst>
-          </a:prstGeom>
-          <a:solidFill>
-            <a:srgbClr val="DCE9FC"/>
-          </a:solidFill>
-          <a:ln w="22225">
-            <a:solidFill>
-              <a:srgbClr val="141414"/>
-            </a:solidFill>
-            <a:prstDash val="solid"/>
-          </a:ln>
-          <a:effectLst>
-            <a:outerShdw sx="100000" sy="100000" kx="0" ky="0" algn="bl" rotWithShape="0" blurRad="101600" dist="38100" dir="2700000">
-              <a:srgbClr val="141414">
-                <a:alpha val="100000"/>
-              </a:srgbClr>
-            </a:outerShdw>
-          </a:effectLst>
-        </p:spPr>
-      </p:sp>
-      <p:sp>
-        <p:nvSpPr>
-          <p:cNvPr id="14" name="Text 12"/>
-          <p:cNvSpPr txBox="1"/>
-          <p:nvPr/>
-        </p:nvSpPr>
-        <p:spPr>
-          <a:xfrm>
-            <a:off x="777240" y="4133088"/>
-            <a:ext cx="1792224" cy="310896"/>
-          </a:xfrm>
-          <a:prstGeom prst="rect">
-            <a:avLst/>
-          </a:prstGeom>
-          <a:noFill/>
-          <a:ln/>
-        </p:spPr>
-        <p:txBody>
-          <a:bodyPr wrap="square" lIns="0" tIns="0" rIns="0" bIns="0" rtlCol="0" anchor="ctr"/>
-          <a:lstStyle/>
-          <a:p>
-            <a:pPr algn="ctr" indent="0" marL="0">
-              <a:buNone/>
-            </a:pPr>
-            <a:r>
-              <a:rPr lang="en-US" sz="1100" b="1" dirty="0">
-                <a:solidFill>
-                  <a:srgbClr val="141414"/>
-                </a:solidFill>
-                <a:latin typeface="Arial" pitchFamily="34" charset="0"/>
-                <a:ea typeface="Arial" pitchFamily="34" charset="-122"/>
-                <a:cs typeface="Arial" pitchFamily="34" charset="-120"/>
-              </a:rPr>
-              <a:t>Serena-grade editing</a:t>
-            </a:r>
-            <a:endParaRPr lang="en-US" sz="1100" dirty="0"/>
-          </a:p>
-        </p:txBody>
-      </p:sp>
-      <p:sp>
-        <p:nvSpPr>
-          <p:cNvPr id="15" name="Text 13"/>
-          <p:cNvSpPr txBox="1"/>
-          <p:nvPr/>
-        </p:nvSpPr>
-        <p:spPr>
-          <a:xfrm>
-            <a:off x="3794760" y="4014216"/>
-            <a:ext cx="7680960" cy="621792"/>
-          </a:xfrm>
-          <a:prstGeom prst="rect">
-            <a:avLst/>
-          </a:prstGeom>
-          <a:noFill/>
-          <a:ln/>
-        </p:spPr>
-        <p:txBody>
-          <a:bodyPr wrap="square" lIns="0" tIns="0" rIns="0" bIns="0" rtlCol="0" anchor="ctr"/>
-          <a:lstStyle/>
-          <a:p>
-            <a:pPr indent="0" marL="0">
-              <a:buNone/>
-            </a:pPr>
-            <a:r>
-              <a:rPr lang="en-US" sz="1350" dirty="0">
-                <a:solidFill>
-                  <a:srgbClr val="141414"/>
-                </a:solidFill>
-                <a:latin typeface="Calibri" pitchFamily="34" charset="0"/>
-                <a:ea typeface="Calibri" pitchFamily="34" charset="-122"/>
-                <a:cs typeface="Calibri" pitchFamily="34" charset="-120"/>
-              </a:rPr>
-              <a:t>create ops + batch apply + formatter contract — agents author Ash DSL safely</a:t>
-            </a:r>
-            <a:endParaRPr lang="en-US" sz="1350" dirty="0"/>
-          </a:p>
-        </p:txBody>
-      </p:sp>
-      <p:sp>
-        <p:nvSpPr>
-          <p:cNvPr id="16" name="Shape 14"/>
-          <p:cNvSpPr/>
-          <p:nvPr/>
-        </p:nvSpPr>
-        <p:spPr>
-          <a:xfrm>
-            <a:off x="502920" y="4928616"/>
-            <a:ext cx="11155680" cy="914400"/>
-          </a:xfrm>
-          <a:prstGeom prst="roundRect">
-            <a:avLst>
-              <a:gd name="adj" fmla="val 6000"/>
-            </a:avLst>
-          </a:prstGeom>
-          <a:solidFill>
-            <a:srgbClr val="FFFFFF"/>
-          </a:solidFill>
-          <a:ln w="25400">
-            <a:solidFill>
-              <a:srgbClr val="141414"/>
-            </a:solidFill>
-            <a:prstDash val="solid"/>
-          </a:ln>
-          <a:effectLst>
-            <a:outerShdw sx="100000" sy="100000" kx="0" ky="0" algn="bl" rotWithShape="0" blurRad="101600" dist="63500" dir="2700000">
-              <a:srgbClr val="141414">
-                <a:alpha val="100000"/>
-              </a:srgbClr>
-            </a:outerShdw>
-          </a:effectLst>
-        </p:spPr>
-      </p:sp>
-      <p:sp>
-        <p:nvSpPr>
-          <p:cNvPr id="17" name="Shape 15"/>
-          <p:cNvSpPr/>
-          <p:nvPr/>
-        </p:nvSpPr>
-        <p:spPr>
-          <a:xfrm>
-            <a:off x="777240" y="5212080"/>
-            <a:ext cx="1567282" cy="310896"/>
+            <a:off x="6611112" y="4526280"/>
+            <a:ext cx="1417320" cy="310896"/>
           </a:xfrm>
           <a:prstGeom prst="roundRect">
             <a:avLst>
@@ -8584,14 +9466,14 @@
       </p:sp>
       <p:sp>
         <p:nvSpPr>
-          <p:cNvPr id="18" name="Text 16"/>
+          <p:cNvPr id="10" name="Text 7"/>
           <p:cNvSpPr txBox="1"/>
           <p:nvPr/>
         </p:nvSpPr>
         <p:spPr>
           <a:xfrm>
-            <a:off x="777240" y="5212080"/>
-            <a:ext cx="1567282" cy="310896"/>
+            <a:off x="6611112" y="4526280"/>
+            <a:ext cx="1417320" cy="310896"/>
           </a:xfrm>
           <a:prstGeom prst="rect">
             <a:avLst/>
@@ -8615,7 +9497,7 @@
                 <a:ea typeface="Arial" pitchFamily="34" charset="-122"/>
                 <a:cs typeface="Arial" pitchFamily="34" charset="-120"/>
               </a:rPr>
-              <a:t>The agent console</a:t>
+              <a:t>instance viewer</a:t>
             </a:r>
             <a:endParaRPr lang="en-US" sz="1100" dirty="0"/>
           </a:p>
@@ -8623,14 +9505,14 @@
       </p:sp>
       <p:sp>
         <p:nvSpPr>
-          <p:cNvPr id="19" name="Text 17"/>
+          <p:cNvPr id="11" name="Text 8"/>
           <p:cNvSpPr txBox="1"/>
           <p:nvPr/>
         </p:nvSpPr>
         <p:spPr>
           <a:xfrm>
-            <a:off x="3794760" y="5093208"/>
-            <a:ext cx="7680960" cy="621792"/>
+            <a:off x="6400800" y="5257800"/>
+            <a:ext cx="5257800" cy="1234440"/>
           </a:xfrm>
           <a:prstGeom prst="rect">
             <a:avLst/>
@@ -8646,17 +9528,17 @@
               <a:buNone/>
             </a:pPr>
             <a:r>
-              <a:rPr lang="en-US" sz="1350" dirty="0">
-                <a:solidFill>
-                  <a:srgbClr val="141414"/>
+              <a:rPr lang="en-US" sz="1250" dirty="0">
+                <a:solidFill>
+                  <a:srgbClr val="5B6472"/>
                 </a:solidFill>
                 <a:latin typeface="Calibri" pitchFamily="34" charset="0"/>
                 <a:ea typeface="Calibri" pitchFamily="34" charset="-122"/>
                 <a:cs typeface="Calibri" pitchFamily="34" charset="-120"/>
               </a:rPr>
-              <a:t>in-app: ask for an interface, it composes and verifies a surface live (LLM-backed, works keyless for browsing)</a:t>
-            </a:r>
-            <a:endParaRPr lang="en-US" sz="1350" dirty="0"/>
+              <a:t>Booking starts the process inside the transaction. Open any visit from the hub: the diagram draws with the current node highlighted — waiting dashed, executing pulsing — and every guarded decision lands in the evidence trail.</a:t>
+            </a:r>
+            <a:endParaRPr lang="en-US" sz="1250" dirty="0"/>
           </a:p>
         </p:txBody>
       </p:sp>

</xml_diff>